<commit_message>
--- updated the pages --- new changes
</commit_message>
<xml_diff>
--- a/docs/drs/Italian_Text_Analyzer_Presentation.pptx
+++ b/docs/drs/Italian_Text_Analyzer_Presentation.pptx
@@ -18,9 +18,9 @@
     <p:sldId id="263" r:id="rId9"/>
     <p:sldId id="264" r:id="rId10"/>
     <p:sldId id="276" r:id="rId11"/>
-    <p:sldId id="277" r:id="rId12"/>
-    <p:sldId id="265" r:id="rId13"/>
-    <p:sldId id="266" r:id="rId14"/>
+    <p:sldId id="265" r:id="rId12"/>
+    <p:sldId id="266" r:id="rId13"/>
+    <p:sldId id="277" r:id="rId14"/>
     <p:sldId id="267" r:id="rId15"/>
     <p:sldId id="268" r:id="rId16"/>
     <p:sldId id="273" r:id="rId17"/>
@@ -496,7 +496,7 @@
     </p:spTree>
     <p:extLst>
       <p:ext uri="{BB962C8B-B14F-4D97-AF65-F5344CB8AC3E}">
-        <p14:creationId xmlns:p14="http://schemas.microsoft.com/office/powerpoint/2010/main" val="3248772191"/>
+        <p14:creationId xmlns:p14="http://schemas.microsoft.com/office/powerpoint/2010/main" val="1024086991"/>
       </p:ext>
     </p:extLst>
   </p:cSld>
@@ -664,7 +664,7 @@
     </p:spTree>
     <p:extLst>
       <p:ext uri="{BB962C8B-B14F-4D97-AF65-F5344CB8AC3E}">
-        <p14:creationId xmlns:p14="http://schemas.microsoft.com/office/powerpoint/2010/main" val="1024086991"/>
+        <p14:creationId xmlns:p14="http://schemas.microsoft.com/office/powerpoint/2010/main" val="3248772191"/>
       </p:ext>
     </p:extLst>
   </p:cSld>
@@ -2492,10 +2492,10 @@
       </p:sp>
       <p:pic>
         <p:nvPicPr>
-          <p:cNvPr id="24" name="Picture 23">
+          <p:cNvPr id="5" name="Picture 4">
             <a:extLst>
               <a:ext uri="{FF2B5EF4-FFF2-40B4-BE49-F238E27FC236}">
-                <a16:creationId xmlns:a16="http://schemas.microsoft.com/office/drawing/2014/main" id="{0DA9F348-C48D-40E6-839F-0A28DD17F9CF}"/>
+                <a16:creationId xmlns:a16="http://schemas.microsoft.com/office/drawing/2014/main" id="{162347A4-8FEB-4582-BDA3-0A63CBF82AAE}"/>
               </a:ext>
             </a:extLst>
           </p:cNvPr>
@@ -2512,8 +2512,38 @@
         </p:blipFill>
         <p:spPr>
           <a:xfrm>
-            <a:off x="1077457" y="1003921"/>
-            <a:ext cx="6989085" cy="3695967"/>
+            <a:off x="967441" y="914400"/>
+            <a:ext cx="6782578" cy="1887243"/>
+          </a:xfrm>
+          <a:prstGeom prst="rect">
+            <a:avLst/>
+          </a:prstGeom>
+        </p:spPr>
+      </p:pic>
+      <p:pic>
+        <p:nvPicPr>
+          <p:cNvPr id="7" name="Picture 6">
+            <a:extLst>
+              <a:ext uri="{FF2B5EF4-FFF2-40B4-BE49-F238E27FC236}">
+                <a16:creationId xmlns:a16="http://schemas.microsoft.com/office/drawing/2014/main" id="{D6EDC5FB-E829-4CA0-9DDF-B8A34545E302}"/>
+              </a:ext>
+            </a:extLst>
+          </p:cNvPr>
+          <p:cNvPicPr>
+            <a:picLocks noChangeAspect="1"/>
+          </p:cNvPicPr>
+          <p:nvPr/>
+        </p:nvPicPr>
+        <p:blipFill>
+          <a:blip r:embed="rId4"/>
+          <a:stretch>
+            <a:fillRect/>
+          </a:stretch>
+        </p:blipFill>
+        <p:spPr>
+          <a:xfrm>
+            <a:off x="967441" y="2801643"/>
+            <a:ext cx="6782578" cy="2163792"/>
           </a:xfrm>
           <a:prstGeom prst="rect">
             <a:avLst/>
@@ -2534,6 +2564,1899 @@
 </file>
 
 <file path=ppt/slides/slide11.xml><?xml version="1.0" encoding="utf-8"?>
+<p:sld xmlns:a="http://schemas.openxmlformats.org/drawingml/2006/main" xmlns:r="http://schemas.openxmlformats.org/officeDocument/2006/relationships" xmlns:p="http://schemas.openxmlformats.org/presentationml/2006/main">
+  <p:cSld name="Slide 10">
+    <p:bg>
+      <p:bgPr>
+        <a:solidFill>
+          <a:srgbClr val="F1F5F9"/>
+        </a:solidFill>
+        <a:effectLst/>
+      </p:bgPr>
+    </p:bg>
+    <p:spTree>
+      <p:nvGrpSpPr>
+        <p:cNvPr id="1" name=""/>
+        <p:cNvGrpSpPr/>
+        <p:nvPr/>
+      </p:nvGrpSpPr>
+      <p:grpSpPr>
+        <a:xfrm>
+          <a:off x="0" y="0"/>
+          <a:ext cx="0" cy="0"/>
+          <a:chOff x="0" y="0"/>
+          <a:chExt cx="0" cy="0"/>
+        </a:xfrm>
+      </p:grpSpPr>
+      <p:sp>
+        <p:nvSpPr>
+          <p:cNvPr id="2" name="Text 0"/>
+          <p:cNvSpPr/>
+          <p:nvPr/>
+        </p:nvSpPr>
+        <p:spPr>
+          <a:xfrm>
+            <a:off x="457200" y="256032"/>
+            <a:ext cx="8229600" cy="594360"/>
+          </a:xfrm>
+          <a:prstGeom prst="rect">
+            <a:avLst/>
+          </a:prstGeom>
+          <a:noFill/>
+          <a:ln/>
+        </p:spPr>
+        <p:txBody>
+          <a:bodyPr wrap="square" rtlCol="0" anchor="ctr"/>
+          <a:lstStyle/>
+          <a:p>
+            <a:pPr marL="0" indent="0">
+              <a:buNone/>
+            </a:pPr>
+            <a:r>
+              <a:rPr lang="en-US" sz="3000" b="1" dirty="0">
+                <a:solidFill>
+                  <a:srgbClr val="0D2137"/>
+                </a:solidFill>
+                <a:latin typeface="Cambria" pitchFamily="34" charset="0"/>
+                <a:ea typeface="Cambria" pitchFamily="34" charset="-122"/>
+                <a:cs typeface="Cambria" pitchFamily="34" charset="-120"/>
+              </a:rPr>
+              <a:t>Redundancy Detection</a:t>
+            </a:r>
+            <a:endParaRPr lang="en-US" sz="3000" dirty="0"/>
+          </a:p>
+        </p:txBody>
+      </p:sp>
+      <p:sp>
+        <p:nvSpPr>
+          <p:cNvPr id="3" name="Shape 1"/>
+          <p:cNvSpPr/>
+          <p:nvPr/>
+        </p:nvSpPr>
+        <p:spPr>
+          <a:xfrm>
+            <a:off x="457200" y="868680"/>
+            <a:ext cx="8229600" cy="27432"/>
+          </a:xfrm>
+          <a:prstGeom prst="rect">
+            <a:avLst/>
+          </a:prstGeom>
+          <a:solidFill>
+            <a:srgbClr val="028090"/>
+          </a:solidFill>
+          <a:ln w="12700">
+            <a:solidFill>
+              <a:srgbClr val="028090"/>
+            </a:solidFill>
+            <a:prstDash val="solid"/>
+          </a:ln>
+        </p:spPr>
+      </p:sp>
+      <p:sp>
+        <p:nvSpPr>
+          <p:cNvPr id="4" name="Text 2"/>
+          <p:cNvSpPr/>
+          <p:nvPr/>
+        </p:nvSpPr>
+        <p:spPr>
+          <a:xfrm>
+            <a:off x="457200" y="1051560"/>
+            <a:ext cx="4023360" cy="411480"/>
+          </a:xfrm>
+          <a:prstGeom prst="rect">
+            <a:avLst/>
+          </a:prstGeom>
+          <a:noFill/>
+          <a:ln/>
+        </p:spPr>
+        <p:txBody>
+          <a:bodyPr wrap="square" rtlCol="0" anchor="ctr"/>
+          <a:lstStyle/>
+          <a:p>
+            <a:pPr marL="0" indent="0">
+              <a:buNone/>
+            </a:pPr>
+            <a:r>
+              <a:rPr lang="en-US" sz="1700" b="1" dirty="0">
+                <a:solidFill>
+                  <a:srgbClr val="028090"/>
+                </a:solidFill>
+                <a:latin typeface="Cambria" pitchFamily="34" charset="0"/>
+                <a:ea typeface="Cambria" pitchFamily="34" charset="-122"/>
+                <a:cs typeface="Cambria" pitchFamily="34" charset="-120"/>
+              </a:rPr>
+              <a:t>Semantic Similarity Analysis</a:t>
+            </a:r>
+            <a:endParaRPr lang="en-US" sz="1700" dirty="0"/>
+          </a:p>
+        </p:txBody>
+      </p:sp>
+      <p:sp>
+        <p:nvSpPr>
+          <p:cNvPr id="6" name="Shape 4"/>
+          <p:cNvSpPr/>
+          <p:nvPr/>
+        </p:nvSpPr>
+        <p:spPr>
+          <a:xfrm>
+            <a:off x="365760" y="2852928"/>
+            <a:ext cx="4023360" cy="640080"/>
+          </a:xfrm>
+          <a:prstGeom prst="roundRect">
+            <a:avLst>
+              <a:gd name="adj" fmla="val 10000"/>
+            </a:avLst>
+          </a:prstGeom>
+          <a:solidFill>
+            <a:srgbClr val="EFF6FF"/>
+          </a:solidFill>
+          <a:ln w="12700">
+            <a:solidFill>
+              <a:srgbClr val="BFDBFE"/>
+            </a:solidFill>
+            <a:prstDash val="solid"/>
+          </a:ln>
+          <a:effectLst>
+            <a:outerShdw blurRad="101600" dist="38100" dir="2700000" algn="bl" rotWithShape="0">
+              <a:srgbClr val="000000">
+                <a:alpha val="12000"/>
+              </a:srgbClr>
+            </a:outerShdw>
+          </a:effectLst>
+        </p:spPr>
+      </p:sp>
+      <p:sp>
+        <p:nvSpPr>
+          <p:cNvPr id="7" name="Text 5"/>
+          <p:cNvSpPr/>
+          <p:nvPr/>
+        </p:nvSpPr>
+        <p:spPr>
+          <a:xfrm>
+            <a:off x="548640" y="2880360"/>
+            <a:ext cx="3657600" cy="274320"/>
+          </a:xfrm>
+          <a:prstGeom prst="rect">
+            <a:avLst/>
+          </a:prstGeom>
+          <a:noFill/>
+          <a:ln/>
+        </p:spPr>
+        <p:txBody>
+          <a:bodyPr wrap="square" rtlCol="0" anchor="ctr"/>
+          <a:lstStyle/>
+          <a:p>
+            <a:pPr marL="0" indent="0">
+              <a:buNone/>
+            </a:pPr>
+            <a:r>
+              <a:rPr lang="en-US" sz="1400" dirty="0">
+                <a:solidFill>
+                  <a:srgbClr val="0070C0"/>
+                </a:solidFill>
+              </a:rPr>
+              <a:t>Sentence-Transformer Embeddings</a:t>
+            </a:r>
+            <a:endParaRPr lang="en-US" sz="1300" dirty="0">
+              <a:solidFill>
+                <a:srgbClr val="0070C0"/>
+              </a:solidFill>
+            </a:endParaRPr>
+          </a:p>
+        </p:txBody>
+      </p:sp>
+      <p:sp>
+        <p:nvSpPr>
+          <p:cNvPr id="8" name="Text 6"/>
+          <p:cNvSpPr/>
+          <p:nvPr/>
+        </p:nvSpPr>
+        <p:spPr>
+          <a:xfrm>
+            <a:off x="548640" y="3154680"/>
+            <a:ext cx="3657600" cy="274320"/>
+          </a:xfrm>
+          <a:prstGeom prst="rect">
+            <a:avLst/>
+          </a:prstGeom>
+          <a:noFill/>
+          <a:ln/>
+        </p:spPr>
+        <p:txBody>
+          <a:bodyPr wrap="square" rtlCol="0" anchor="ctr"/>
+          <a:lstStyle/>
+          <a:p>
+            <a:pPr marL="0" indent="0">
+              <a:buNone/>
+            </a:pPr>
+            <a:r>
+              <a:rPr lang="tr-TR" sz="1100" dirty="0">
+                <a:solidFill>
+                  <a:srgbClr val="64748B"/>
+                </a:solidFill>
+                <a:latin typeface="Calibri" pitchFamily="34" charset="0"/>
+                <a:ea typeface="Calibri" pitchFamily="34" charset="-122"/>
+                <a:cs typeface="Calibri" pitchFamily="34" charset="-120"/>
+              </a:rPr>
+              <a:t>Multilingual semantic sentence vectors</a:t>
+            </a:r>
+            <a:endParaRPr lang="en-US" sz="1100" dirty="0"/>
+          </a:p>
+        </p:txBody>
+      </p:sp>
+      <p:sp>
+        <p:nvSpPr>
+          <p:cNvPr id="9" name="Shape 7"/>
+          <p:cNvSpPr/>
+          <p:nvPr/>
+        </p:nvSpPr>
+        <p:spPr>
+          <a:xfrm>
+            <a:off x="365760" y="3602736"/>
+            <a:ext cx="4023360" cy="640080"/>
+          </a:xfrm>
+          <a:prstGeom prst="roundRect">
+            <a:avLst>
+              <a:gd name="adj" fmla="val 10000"/>
+            </a:avLst>
+          </a:prstGeom>
+          <a:solidFill>
+            <a:srgbClr val="EFF6FF"/>
+          </a:solidFill>
+          <a:ln w="12700">
+            <a:solidFill>
+              <a:srgbClr val="BFDBFE"/>
+            </a:solidFill>
+            <a:prstDash val="solid"/>
+          </a:ln>
+          <a:effectLst>
+            <a:outerShdw blurRad="101600" dist="38100" dir="2700000" algn="bl" rotWithShape="0">
+              <a:srgbClr val="000000">
+                <a:alpha val="12000"/>
+              </a:srgbClr>
+            </a:outerShdw>
+          </a:effectLst>
+        </p:spPr>
+      </p:sp>
+      <p:sp>
+        <p:nvSpPr>
+          <p:cNvPr id="10" name="Text 8"/>
+          <p:cNvSpPr/>
+          <p:nvPr/>
+        </p:nvSpPr>
+        <p:spPr>
+          <a:xfrm>
+            <a:off x="548640" y="3630168"/>
+            <a:ext cx="3657600" cy="274320"/>
+          </a:xfrm>
+          <a:prstGeom prst="rect">
+            <a:avLst/>
+          </a:prstGeom>
+          <a:noFill/>
+          <a:ln/>
+        </p:spPr>
+        <p:txBody>
+          <a:bodyPr wrap="square" rtlCol="0" anchor="ctr"/>
+          <a:lstStyle/>
+          <a:p>
+            <a:pPr marL="0" indent="0">
+              <a:buNone/>
+            </a:pPr>
+            <a:r>
+              <a:rPr lang="tr-TR" sz="1300" b="1" dirty="0">
+                <a:solidFill>
+                  <a:srgbClr val="0070C0"/>
+                </a:solidFill>
+                <a:latin typeface="Cambria" pitchFamily="34" charset="0"/>
+                <a:ea typeface="Cambria" pitchFamily="34" charset="-122"/>
+              </a:rPr>
+              <a:t>Cosine Similarity Matrix</a:t>
+            </a:r>
+            <a:endParaRPr lang="en-US" sz="1300" dirty="0">
+              <a:solidFill>
+                <a:srgbClr val="0070C0"/>
+              </a:solidFill>
+            </a:endParaRPr>
+          </a:p>
+        </p:txBody>
+      </p:sp>
+      <p:sp>
+        <p:nvSpPr>
+          <p:cNvPr id="11" name="Text 9"/>
+          <p:cNvSpPr/>
+          <p:nvPr/>
+        </p:nvSpPr>
+        <p:spPr>
+          <a:xfrm>
+            <a:off x="548640" y="3904488"/>
+            <a:ext cx="3657600" cy="274320"/>
+          </a:xfrm>
+          <a:prstGeom prst="rect">
+            <a:avLst/>
+          </a:prstGeom>
+          <a:noFill/>
+          <a:ln/>
+        </p:spPr>
+        <p:txBody>
+          <a:bodyPr wrap="square" rtlCol="0" anchor="ctr"/>
+          <a:lstStyle/>
+          <a:p>
+            <a:pPr marL="0" indent="0">
+              <a:buNone/>
+            </a:pPr>
+            <a:r>
+              <a:rPr lang="tr-TR" sz="1100" dirty="0">
+                <a:solidFill>
+                  <a:srgbClr val="64748B"/>
+                </a:solidFill>
+                <a:latin typeface="Calibri" pitchFamily="34" charset="0"/>
+                <a:ea typeface="Calibri" pitchFamily="34" charset="-122"/>
+                <a:cs typeface="Calibri" pitchFamily="34" charset="-120"/>
+              </a:rPr>
+              <a:t>Compares every sentence pair</a:t>
+            </a:r>
+            <a:endParaRPr lang="en-US" sz="1100" dirty="0"/>
+          </a:p>
+        </p:txBody>
+      </p:sp>
+      <p:sp>
+        <p:nvSpPr>
+          <p:cNvPr id="12" name="Shape 10"/>
+          <p:cNvSpPr/>
+          <p:nvPr/>
+        </p:nvSpPr>
+        <p:spPr>
+          <a:xfrm>
+            <a:off x="365760" y="4379976"/>
+            <a:ext cx="4023360" cy="640080"/>
+          </a:xfrm>
+          <a:prstGeom prst="roundRect">
+            <a:avLst>
+              <a:gd name="adj" fmla="val 10000"/>
+            </a:avLst>
+          </a:prstGeom>
+          <a:solidFill>
+            <a:srgbClr val="EFF6FF"/>
+          </a:solidFill>
+          <a:ln w="12700">
+            <a:solidFill>
+              <a:srgbClr val="BFDBFE"/>
+            </a:solidFill>
+            <a:prstDash val="solid"/>
+          </a:ln>
+          <a:effectLst>
+            <a:outerShdw blurRad="101600" dist="38100" dir="2700000" algn="bl" rotWithShape="0">
+              <a:srgbClr val="000000">
+                <a:alpha val="12000"/>
+              </a:srgbClr>
+            </a:outerShdw>
+          </a:effectLst>
+        </p:spPr>
+      </p:sp>
+      <p:sp>
+        <p:nvSpPr>
+          <p:cNvPr id="13" name="Text 11"/>
+          <p:cNvSpPr/>
+          <p:nvPr/>
+        </p:nvSpPr>
+        <p:spPr>
+          <a:xfrm>
+            <a:off x="548640" y="4379976"/>
+            <a:ext cx="3657600" cy="274320"/>
+          </a:xfrm>
+          <a:prstGeom prst="rect">
+            <a:avLst/>
+          </a:prstGeom>
+          <a:noFill/>
+          <a:ln/>
+        </p:spPr>
+        <p:txBody>
+          <a:bodyPr wrap="square" rtlCol="0" anchor="ctr"/>
+          <a:lstStyle/>
+          <a:p>
+            <a:pPr marL="0" indent="0">
+              <a:buNone/>
+            </a:pPr>
+            <a:r>
+              <a:rPr lang="en-US" sz="1300" b="1" dirty="0">
+                <a:solidFill>
+                  <a:srgbClr val="0070C0"/>
+                </a:solidFill>
+                <a:latin typeface="Cambria" pitchFamily="34" charset="0"/>
+                <a:ea typeface="Cambria" pitchFamily="34" charset="-122"/>
+                <a:cs typeface="Cambria" pitchFamily="34" charset="-120"/>
+              </a:rPr>
+              <a:t>Threshold</a:t>
+            </a:r>
+            <a:r>
+              <a:rPr lang="tr-TR" sz="1300" b="1" dirty="0">
+                <a:solidFill>
+                  <a:srgbClr val="0070C0"/>
+                </a:solidFill>
+                <a:latin typeface="Cambria" pitchFamily="34" charset="0"/>
+                <a:ea typeface="Cambria" pitchFamily="34" charset="-122"/>
+                <a:cs typeface="Cambria" pitchFamily="34" charset="-120"/>
+              </a:rPr>
+              <a:t> Classification</a:t>
+            </a:r>
+            <a:endParaRPr lang="en-US" sz="1300" dirty="0">
+              <a:solidFill>
+                <a:srgbClr val="0070C0"/>
+              </a:solidFill>
+            </a:endParaRPr>
+          </a:p>
+        </p:txBody>
+      </p:sp>
+      <p:sp>
+        <p:nvSpPr>
+          <p:cNvPr id="14" name="Text 12"/>
+          <p:cNvSpPr/>
+          <p:nvPr/>
+        </p:nvSpPr>
+        <p:spPr>
+          <a:xfrm>
+            <a:off x="548640" y="4654296"/>
+            <a:ext cx="3657600" cy="274320"/>
+          </a:xfrm>
+          <a:prstGeom prst="rect">
+            <a:avLst/>
+          </a:prstGeom>
+          <a:noFill/>
+          <a:ln/>
+        </p:spPr>
+        <p:txBody>
+          <a:bodyPr wrap="square" rtlCol="0" anchor="ctr"/>
+          <a:lstStyle/>
+          <a:p>
+            <a:pPr marL="0" indent="0">
+              <a:buNone/>
+            </a:pPr>
+            <a:r>
+              <a:rPr lang="tr-TR" sz="1100" dirty="0">
+                <a:solidFill>
+                  <a:srgbClr val="64748B"/>
+                </a:solidFill>
+                <a:latin typeface="Calibri" pitchFamily="34" charset="0"/>
+                <a:ea typeface="Calibri" pitchFamily="34" charset="-122"/>
+                <a:cs typeface="Calibri" pitchFamily="34" charset="-120"/>
+              </a:rPr>
+              <a:t>Merge Candidate/ Manual Review</a:t>
+            </a:r>
+            <a:endParaRPr lang="en-US" sz="1100" dirty="0"/>
+          </a:p>
+        </p:txBody>
+      </p:sp>
+      <p:sp>
+        <p:nvSpPr>
+          <p:cNvPr id="15" name="Shape 13"/>
+          <p:cNvSpPr/>
+          <p:nvPr/>
+        </p:nvSpPr>
+        <p:spPr>
+          <a:xfrm>
+            <a:off x="4709160" y="1271016"/>
+            <a:ext cx="4023360" cy="3749040"/>
+          </a:xfrm>
+          <a:prstGeom prst="roundRect">
+            <a:avLst>
+              <a:gd name="adj" fmla="val 2439"/>
+            </a:avLst>
+          </a:prstGeom>
+          <a:solidFill>
+            <a:srgbClr val="FFFFFF"/>
+          </a:solidFill>
+          <a:ln w="12700">
+            <a:solidFill>
+              <a:srgbClr val="E2E8F0"/>
+            </a:solidFill>
+            <a:prstDash val="solid"/>
+          </a:ln>
+          <a:effectLst>
+            <a:outerShdw blurRad="101600" dist="38100" dir="2700000" algn="bl" rotWithShape="0">
+              <a:srgbClr val="000000">
+                <a:alpha val="12000"/>
+              </a:srgbClr>
+            </a:outerShdw>
+          </a:effectLst>
+        </p:spPr>
+      </p:sp>
+      <p:sp>
+        <p:nvSpPr>
+          <p:cNvPr id="16" name="Text 14"/>
+          <p:cNvSpPr/>
+          <p:nvPr/>
+        </p:nvSpPr>
+        <p:spPr>
+          <a:xfrm>
+            <a:off x="4937760" y="1417320"/>
+            <a:ext cx="3657600" cy="365760"/>
+          </a:xfrm>
+          <a:prstGeom prst="rect">
+            <a:avLst/>
+          </a:prstGeom>
+          <a:noFill/>
+          <a:ln/>
+        </p:spPr>
+        <p:txBody>
+          <a:bodyPr wrap="square" rtlCol="0" anchor="ctr"/>
+          <a:lstStyle/>
+          <a:p>
+            <a:pPr marL="0" indent="0">
+              <a:buNone/>
+            </a:pPr>
+            <a:r>
+              <a:rPr lang="en-US" sz="1500" b="1" dirty="0">
+                <a:solidFill>
+                  <a:srgbClr val="028090"/>
+                </a:solidFill>
+                <a:latin typeface="Cambria" pitchFamily="34" charset="0"/>
+                <a:ea typeface="Cambria" pitchFamily="34" charset="-122"/>
+                <a:cs typeface="Cambria" pitchFamily="34" charset="-120"/>
+              </a:rPr>
+              <a:t>Example</a:t>
+            </a:r>
+            <a:endParaRPr lang="en-US" sz="1500" dirty="0"/>
+          </a:p>
+        </p:txBody>
+      </p:sp>
+      <p:sp>
+        <p:nvSpPr>
+          <p:cNvPr id="17" name="Shape 15"/>
+          <p:cNvSpPr/>
+          <p:nvPr/>
+        </p:nvSpPr>
+        <p:spPr>
+          <a:xfrm>
+            <a:off x="4937760" y="1856232"/>
+            <a:ext cx="3566160" cy="594360"/>
+          </a:xfrm>
+          <a:prstGeom prst="roundRect">
+            <a:avLst>
+              <a:gd name="adj" fmla="val 9231"/>
+            </a:avLst>
+          </a:prstGeom>
+          <a:solidFill>
+            <a:srgbClr val="0F172A"/>
+          </a:solidFill>
+          <a:ln w="12700">
+            <a:solidFill>
+              <a:srgbClr val="1E3A5F"/>
+            </a:solidFill>
+            <a:prstDash val="solid"/>
+          </a:ln>
+        </p:spPr>
+      </p:sp>
+      <p:sp>
+        <p:nvSpPr>
+          <p:cNvPr id="18" name="Text 16"/>
+          <p:cNvSpPr/>
+          <p:nvPr/>
+        </p:nvSpPr>
+        <p:spPr>
+          <a:xfrm>
+            <a:off x="5029200" y="1856232"/>
+            <a:ext cx="3383280" cy="594360"/>
+          </a:xfrm>
+          <a:prstGeom prst="rect">
+            <a:avLst/>
+          </a:prstGeom>
+          <a:noFill/>
+          <a:ln/>
+        </p:spPr>
+        <p:txBody>
+          <a:bodyPr wrap="square" rtlCol="0" anchor="ctr"/>
+          <a:lstStyle/>
+          <a:p>
+            <a:pPr marL="0" indent="0">
+              <a:buNone/>
+            </a:pPr>
+            <a:r>
+              <a:rPr lang="en-US" sz="1100" i="1" dirty="0">
+                <a:solidFill>
+                  <a:srgbClr val="FCA5A5"/>
+                </a:solidFill>
+                <a:latin typeface="Courier New" pitchFamily="34" charset="0"/>
+                <a:ea typeface="Courier New" pitchFamily="34" charset="-122"/>
+                <a:cs typeface="Courier New" pitchFamily="34" charset="-120"/>
+              </a:rPr>
+              <a:t>Le vendite sono diminuite nel terzo trimestre.</a:t>
+            </a:r>
+            <a:endParaRPr lang="en-US" sz="1100" dirty="0"/>
+          </a:p>
+        </p:txBody>
+      </p:sp>
+      <p:sp>
+        <p:nvSpPr>
+          <p:cNvPr id="19" name="Text 17"/>
+          <p:cNvSpPr/>
+          <p:nvPr/>
+        </p:nvSpPr>
+        <p:spPr>
+          <a:xfrm>
+            <a:off x="4937760" y="2514600"/>
+            <a:ext cx="3566160" cy="274320"/>
+          </a:xfrm>
+          <a:prstGeom prst="rect">
+            <a:avLst/>
+          </a:prstGeom>
+          <a:noFill/>
+          <a:ln/>
+        </p:spPr>
+        <p:txBody>
+          <a:bodyPr wrap="square" rtlCol="0" anchor="ctr"/>
+          <a:lstStyle/>
+          <a:p>
+            <a:pPr marL="0" indent="0" algn="ctr">
+              <a:buNone/>
+            </a:pPr>
+            <a:r>
+              <a:rPr lang="en-US" sz="900" b="1" kern="0" spc="200" dirty="0">
+                <a:solidFill>
+                  <a:srgbClr val="92400E"/>
+                </a:solidFill>
+                <a:latin typeface="Calibri" pitchFamily="34" charset="0"/>
+                <a:ea typeface="Calibri" pitchFamily="34" charset="-122"/>
+                <a:cs typeface="Calibri" pitchFamily="34" charset="-120"/>
+              </a:rPr>
+              <a:t>SIMILAR MEANING</a:t>
+            </a:r>
+            <a:endParaRPr lang="en-US" sz="900" dirty="0"/>
+          </a:p>
+        </p:txBody>
+      </p:sp>
+      <p:sp>
+        <p:nvSpPr>
+          <p:cNvPr id="20" name="Shape 18"/>
+          <p:cNvSpPr/>
+          <p:nvPr/>
+        </p:nvSpPr>
+        <p:spPr>
+          <a:xfrm>
+            <a:off x="4937760" y="2807208"/>
+            <a:ext cx="3566160" cy="594360"/>
+          </a:xfrm>
+          <a:prstGeom prst="roundRect">
+            <a:avLst>
+              <a:gd name="adj" fmla="val 9231"/>
+            </a:avLst>
+          </a:prstGeom>
+          <a:solidFill>
+            <a:srgbClr val="0F172A"/>
+          </a:solidFill>
+          <a:ln w="12700">
+            <a:solidFill>
+              <a:srgbClr val="1E3A5F"/>
+            </a:solidFill>
+            <a:prstDash val="solid"/>
+          </a:ln>
+        </p:spPr>
+      </p:sp>
+      <p:sp>
+        <p:nvSpPr>
+          <p:cNvPr id="21" name="Text 19"/>
+          <p:cNvSpPr/>
+          <p:nvPr/>
+        </p:nvSpPr>
+        <p:spPr>
+          <a:xfrm>
+            <a:off x="5029200" y="2807208"/>
+            <a:ext cx="3383280" cy="594360"/>
+          </a:xfrm>
+          <a:prstGeom prst="rect">
+            <a:avLst/>
+          </a:prstGeom>
+          <a:noFill/>
+          <a:ln/>
+        </p:spPr>
+        <p:txBody>
+          <a:bodyPr wrap="square" rtlCol="0" anchor="ctr"/>
+          <a:lstStyle/>
+          <a:p>
+            <a:pPr marL="0" indent="0">
+              <a:buNone/>
+            </a:pPr>
+            <a:r>
+              <a:rPr lang="en-US" sz="1100" i="1" dirty="0">
+                <a:solidFill>
+                  <a:srgbClr val="FCA5A5"/>
+                </a:solidFill>
+                <a:latin typeface="Courier New" pitchFamily="34" charset="0"/>
+                <a:ea typeface="Courier New" pitchFamily="34" charset="-122"/>
+                <a:cs typeface="Courier New" pitchFamily="34" charset="-120"/>
+              </a:rPr>
+              <a:t>Nel terzo trimestre le vendite hanno registrato un calo.</a:t>
+            </a:r>
+            <a:endParaRPr lang="en-US" sz="1100" dirty="0"/>
+          </a:p>
+        </p:txBody>
+      </p:sp>
+      <p:sp>
+        <p:nvSpPr>
+          <p:cNvPr id="22" name="Shape 20"/>
+          <p:cNvSpPr/>
+          <p:nvPr/>
+        </p:nvSpPr>
+        <p:spPr>
+          <a:xfrm>
+            <a:off x="4937760" y="3520440"/>
+            <a:ext cx="3566160" cy="457200"/>
+          </a:xfrm>
+          <a:prstGeom prst="roundRect">
+            <a:avLst>
+              <a:gd name="adj" fmla="val 12000"/>
+            </a:avLst>
+          </a:prstGeom>
+          <a:solidFill>
+            <a:srgbClr val="FFFBEB"/>
+          </a:solidFill>
+          <a:ln w="12700">
+            <a:solidFill>
+              <a:srgbClr val="FDE68A"/>
+            </a:solidFill>
+            <a:prstDash val="solid"/>
+          </a:ln>
+        </p:spPr>
+      </p:sp>
+      <p:sp>
+        <p:nvSpPr>
+          <p:cNvPr id="23" name="Text 21"/>
+          <p:cNvSpPr/>
+          <p:nvPr/>
+        </p:nvSpPr>
+        <p:spPr>
+          <a:xfrm>
+            <a:off x="5029200" y="3538728"/>
+            <a:ext cx="3383280" cy="246888"/>
+          </a:xfrm>
+          <a:prstGeom prst="rect">
+            <a:avLst/>
+          </a:prstGeom>
+          <a:noFill/>
+          <a:ln/>
+        </p:spPr>
+        <p:txBody>
+          <a:bodyPr wrap="square" rtlCol="0" anchor="ctr"/>
+          <a:lstStyle/>
+          <a:p>
+            <a:pPr marL="0" indent="0">
+              <a:buNone/>
+            </a:pPr>
+            <a:r>
+              <a:rPr lang="en-US" sz="1200" b="1" dirty="0">
+                <a:solidFill>
+                  <a:srgbClr val="92400E"/>
+                </a:solidFill>
+                <a:latin typeface="Courier New" pitchFamily="34" charset="0"/>
+                <a:ea typeface="Courier New" pitchFamily="34" charset="-122"/>
+                <a:cs typeface="Courier New" pitchFamily="34" charset="-120"/>
+              </a:rPr>
+              <a:t>Similarity &gt; threshold</a:t>
+            </a:r>
+            <a:endParaRPr lang="en-US" sz="1200" dirty="0"/>
+          </a:p>
+        </p:txBody>
+      </p:sp>
+      <p:sp>
+        <p:nvSpPr>
+          <p:cNvPr id="24" name="Text 22"/>
+          <p:cNvSpPr/>
+          <p:nvPr/>
+        </p:nvSpPr>
+        <p:spPr>
+          <a:xfrm>
+            <a:off x="5029200" y="3776472"/>
+            <a:ext cx="3383280" cy="201168"/>
+          </a:xfrm>
+          <a:prstGeom prst="rect">
+            <a:avLst/>
+          </a:prstGeom>
+          <a:noFill/>
+          <a:ln/>
+        </p:spPr>
+        <p:txBody>
+          <a:bodyPr wrap="square" rtlCol="0" anchor="ctr"/>
+          <a:lstStyle/>
+          <a:p>
+            <a:pPr marL="0" indent="0">
+              <a:buNone/>
+            </a:pPr>
+            <a:r>
+              <a:rPr lang="en-US" sz="1100" i="1" dirty="0">
+                <a:solidFill>
+                  <a:srgbClr val="C0392B"/>
+                </a:solidFill>
+                <a:latin typeface="Calibri" pitchFamily="34" charset="0"/>
+                <a:ea typeface="Calibri" pitchFamily="34" charset="-122"/>
+                <a:cs typeface="Calibri" pitchFamily="34" charset="-120"/>
+              </a:rPr>
+              <a:t>→ Flagged as redundant</a:t>
+            </a:r>
+            <a:endParaRPr lang="en-US" sz="1100" dirty="0"/>
+          </a:p>
+        </p:txBody>
+      </p:sp>
+      <p:sp>
+        <p:nvSpPr>
+          <p:cNvPr id="26" name="TextBox 25">
+            <a:extLst>
+              <a:ext uri="{FF2B5EF4-FFF2-40B4-BE49-F238E27FC236}">
+                <a16:creationId xmlns:a16="http://schemas.microsoft.com/office/drawing/2014/main" id="{EF966B74-3284-4610-8D9F-95ACA56A5E10}"/>
+              </a:ext>
+            </a:extLst>
+          </p:cNvPr>
+          <p:cNvSpPr txBox="1"/>
+          <p:nvPr/>
+        </p:nvSpPr>
+        <p:spPr>
+          <a:xfrm>
+            <a:off x="320040" y="1439342"/>
+            <a:ext cx="4160520" cy="1384995"/>
+          </a:xfrm>
+          <a:prstGeom prst="rect">
+            <a:avLst/>
+          </a:prstGeom>
+          <a:noFill/>
+        </p:spPr>
+        <p:txBody>
+          <a:bodyPr wrap="square">
+            <a:spAutoFit/>
+          </a:bodyPr>
+          <a:lstStyle/>
+          <a:p>
+            <a:r>
+              <a:rPr lang="en-US" sz="1050" dirty="0"/>
+              <a:t>The system uses a multilingual Sentence-Transformer model to compare the meaning of complete sentences, not only individual words.</a:t>
+            </a:r>
+          </a:p>
+          <a:p>
+            <a:r>
+              <a:rPr lang="en-US" sz="1050" dirty="0"/>
+              <a:t>Each sentence is converted into a semantic vector. Then the system calculates cosine similarity between all sentence pairs.</a:t>
+            </a:r>
+          </a:p>
+          <a:p>
+            <a:r>
+              <a:rPr lang="en-US" sz="1050" dirty="0"/>
+              <a:t>If the similarity score is high, the pair is classified as:</a:t>
+            </a:r>
+          </a:p>
+          <a:p>
+            <a:pPr>
+              <a:buFont typeface="Arial" panose="020B0604020202020204" pitchFamily="34" charset="0"/>
+              <a:buChar char="•"/>
+            </a:pPr>
+            <a:r>
+              <a:rPr lang="en-US" sz="1050" b="1" dirty="0"/>
+              <a:t>Duplicate</a:t>
+            </a:r>
+            <a:r>
+              <a:rPr lang="en-US" sz="1050" dirty="0"/>
+              <a:t>: almost identical meaning </a:t>
+            </a:r>
+          </a:p>
+          <a:p>
+            <a:pPr>
+              <a:buFont typeface="Arial" panose="020B0604020202020204" pitchFamily="34" charset="0"/>
+              <a:buChar char="•"/>
+            </a:pPr>
+            <a:r>
+              <a:rPr lang="en-US" sz="1050" b="1" dirty="0"/>
+              <a:t>Manual review</a:t>
+            </a:r>
+            <a:r>
+              <a:rPr lang="en-US" sz="1050" dirty="0"/>
+              <a:t>: user chooses which sentence to keep </a:t>
+            </a:r>
+          </a:p>
+          <a:p>
+            <a:pPr>
+              <a:buFont typeface="Arial" panose="020B0604020202020204" pitchFamily="34" charset="0"/>
+              <a:buChar char="•"/>
+            </a:pPr>
+            <a:r>
+              <a:rPr lang="en-US" sz="1050" b="1" dirty="0"/>
+              <a:t>Merge candidate</a:t>
+            </a:r>
+            <a:r>
+              <a:rPr lang="en-US" sz="1050" dirty="0"/>
+              <a:t>: the system may merge them during rewriting</a:t>
+            </a:r>
+          </a:p>
+        </p:txBody>
+      </p:sp>
+    </p:spTree>
+  </p:cSld>
+  <p:clrMapOvr>
+    <a:masterClrMapping/>
+  </p:clrMapOvr>
+</p:sld>
+</file>
+
+<file path=ppt/slides/slide12.xml><?xml version="1.0" encoding="utf-8"?>
+<p:sld xmlns:a="http://schemas.openxmlformats.org/drawingml/2006/main" xmlns:r="http://schemas.openxmlformats.org/officeDocument/2006/relationships" xmlns:p="http://schemas.openxmlformats.org/presentationml/2006/main">
+  <p:cSld name="Slide 11">
+    <p:bg>
+      <p:bgPr>
+        <a:solidFill>
+          <a:srgbClr val="0D2137"/>
+        </a:solidFill>
+        <a:effectLst/>
+      </p:bgPr>
+    </p:bg>
+    <p:spTree>
+      <p:nvGrpSpPr>
+        <p:cNvPr id="1" name=""/>
+        <p:cNvGrpSpPr/>
+        <p:nvPr/>
+      </p:nvGrpSpPr>
+      <p:grpSpPr>
+        <a:xfrm>
+          <a:off x="0" y="0"/>
+          <a:ext cx="0" cy="0"/>
+          <a:chOff x="0" y="0"/>
+          <a:chExt cx="0" cy="0"/>
+        </a:xfrm>
+      </p:grpSpPr>
+      <p:sp>
+        <p:nvSpPr>
+          <p:cNvPr id="2" name="Text 0"/>
+          <p:cNvSpPr/>
+          <p:nvPr/>
+        </p:nvSpPr>
+        <p:spPr>
+          <a:xfrm>
+            <a:off x="457200" y="182880"/>
+            <a:ext cx="7498080" cy="548640"/>
+          </a:xfrm>
+          <a:prstGeom prst="rect">
+            <a:avLst/>
+          </a:prstGeom>
+          <a:noFill/>
+          <a:ln/>
+        </p:spPr>
+        <p:txBody>
+          <a:bodyPr wrap="square" rtlCol="0" anchor="ctr"/>
+          <a:lstStyle/>
+          <a:p>
+            <a:pPr marL="0" indent="0">
+              <a:buNone/>
+            </a:pPr>
+            <a:r>
+              <a:rPr lang="en-US" sz="2800" b="1" dirty="0">
+                <a:solidFill>
+                  <a:srgbClr val="FFFFFF"/>
+                </a:solidFill>
+                <a:latin typeface="Cambria" pitchFamily="34" charset="0"/>
+                <a:ea typeface="Cambria" pitchFamily="34" charset="-122"/>
+                <a:cs typeface="Cambria" pitchFamily="34" charset="-120"/>
+              </a:rPr>
+              <a:t>Pre-Merging Strategy</a:t>
+            </a:r>
+            <a:endParaRPr lang="en-US" sz="2800" dirty="0"/>
+          </a:p>
+        </p:txBody>
+      </p:sp>
+      <p:sp>
+        <p:nvSpPr>
+          <p:cNvPr id="3" name="Shape 1"/>
+          <p:cNvSpPr/>
+          <p:nvPr/>
+        </p:nvSpPr>
+        <p:spPr>
+          <a:xfrm>
+            <a:off x="7498080" y="182880"/>
+            <a:ext cx="1371600" cy="457200"/>
+          </a:xfrm>
+          <a:prstGeom prst="roundRect">
+            <a:avLst>
+              <a:gd name="adj" fmla="val 12000"/>
+            </a:avLst>
+          </a:prstGeom>
+          <a:solidFill>
+            <a:srgbClr val="C0392B"/>
+          </a:solidFill>
+          <a:ln w="12700">
+            <a:solidFill>
+              <a:srgbClr val="C0392B"/>
+            </a:solidFill>
+            <a:prstDash val="solid"/>
+          </a:ln>
+        </p:spPr>
+      </p:sp>
+      <p:sp>
+        <p:nvSpPr>
+          <p:cNvPr id="5" name="Text 3"/>
+          <p:cNvSpPr/>
+          <p:nvPr/>
+        </p:nvSpPr>
+        <p:spPr>
+          <a:xfrm>
+            <a:off x="457200" y="777240"/>
+            <a:ext cx="8229600" cy="365760"/>
+          </a:xfrm>
+          <a:prstGeom prst="rect">
+            <a:avLst/>
+          </a:prstGeom>
+          <a:noFill/>
+          <a:ln/>
+        </p:spPr>
+        <p:txBody>
+          <a:bodyPr wrap="square" rtlCol="0" anchor="ctr"/>
+          <a:lstStyle/>
+          <a:p>
+            <a:pPr marL="0" indent="0">
+              <a:buNone/>
+            </a:pPr>
+            <a:r>
+              <a:rPr lang="en-US" sz="1300" i="1" dirty="0">
+                <a:solidFill>
+                  <a:srgbClr val="94A3B8"/>
+                </a:solidFill>
+                <a:latin typeface="Calibri" pitchFamily="34" charset="0"/>
+                <a:ea typeface="Calibri" pitchFamily="34" charset="-122"/>
+                <a:cs typeface="Calibri" pitchFamily="34" charset="-120"/>
+              </a:rPr>
+              <a:t>Why is this needed?  If we directly pass both sentences to the AI, information may be lost.</a:t>
+            </a:r>
+            <a:endParaRPr lang="en-US" sz="1300" dirty="0"/>
+          </a:p>
+        </p:txBody>
+      </p:sp>
+      <p:sp>
+        <p:nvSpPr>
+          <p:cNvPr id="6" name="Shape 4"/>
+          <p:cNvSpPr/>
+          <p:nvPr/>
+        </p:nvSpPr>
+        <p:spPr>
+          <a:xfrm>
+            <a:off x="3200400" y="1234440"/>
+            <a:ext cx="3200400" cy="502920"/>
+          </a:xfrm>
+          <a:prstGeom prst="roundRect">
+            <a:avLst>
+              <a:gd name="adj" fmla="val 14545"/>
+            </a:avLst>
+          </a:prstGeom>
+          <a:solidFill>
+            <a:srgbClr val="1E3A5F"/>
+          </a:solidFill>
+          <a:ln w="12700">
+            <a:solidFill>
+              <a:srgbClr val="02C39A"/>
+            </a:solidFill>
+            <a:prstDash val="solid"/>
+          </a:ln>
+        </p:spPr>
+      </p:sp>
+      <p:sp>
+        <p:nvSpPr>
+          <p:cNvPr id="7" name="Text 5"/>
+          <p:cNvSpPr/>
+          <p:nvPr/>
+        </p:nvSpPr>
+        <p:spPr>
+          <a:xfrm>
+            <a:off x="3200400" y="1234440"/>
+            <a:ext cx="3200400" cy="502920"/>
+          </a:xfrm>
+          <a:prstGeom prst="rect">
+            <a:avLst/>
+          </a:prstGeom>
+          <a:noFill/>
+          <a:ln/>
+        </p:spPr>
+        <p:txBody>
+          <a:bodyPr wrap="square" rtlCol="0" anchor="ctr"/>
+          <a:lstStyle/>
+          <a:p>
+            <a:pPr marL="0" indent="0" algn="ctr">
+              <a:buNone/>
+            </a:pPr>
+            <a:r>
+              <a:rPr lang="en-US" sz="1400" b="1" dirty="0">
+                <a:solidFill>
+                  <a:srgbClr val="02C39A"/>
+                </a:solidFill>
+                <a:latin typeface="Calibri" pitchFamily="34" charset="0"/>
+                <a:ea typeface="Calibri" pitchFamily="34" charset="-122"/>
+                <a:cs typeface="Calibri" pitchFamily="34" charset="-120"/>
+              </a:rPr>
+              <a:t>Sentence Pair</a:t>
+            </a:r>
+            <a:endParaRPr lang="en-US" sz="1400" dirty="0"/>
+          </a:p>
+        </p:txBody>
+      </p:sp>
+      <p:sp>
+        <p:nvSpPr>
+          <p:cNvPr id="8" name="Text 6"/>
+          <p:cNvSpPr/>
+          <p:nvPr/>
+        </p:nvSpPr>
+        <p:spPr>
+          <a:xfrm>
+            <a:off x="3200400" y="1737360"/>
+            <a:ext cx="3200400" cy="320040"/>
+          </a:xfrm>
+          <a:prstGeom prst="rect">
+            <a:avLst/>
+          </a:prstGeom>
+          <a:noFill/>
+          <a:ln/>
+        </p:spPr>
+        <p:txBody>
+          <a:bodyPr wrap="square" rtlCol="0" anchor="ctr"/>
+          <a:lstStyle/>
+          <a:p>
+            <a:pPr marL="0" indent="0" algn="ctr">
+              <a:buNone/>
+            </a:pPr>
+            <a:r>
+              <a:rPr lang="en-US" sz="1600" dirty="0">
+                <a:solidFill>
+                  <a:srgbClr val="94A3B8"/>
+                </a:solidFill>
+              </a:rPr>
+              <a:t>↓</a:t>
+            </a:r>
+            <a:endParaRPr lang="en-US" sz="1600" dirty="0"/>
+          </a:p>
+        </p:txBody>
+      </p:sp>
+      <p:sp>
+        <p:nvSpPr>
+          <p:cNvPr id="9" name="Shape 7"/>
+          <p:cNvSpPr/>
+          <p:nvPr/>
+        </p:nvSpPr>
+        <p:spPr>
+          <a:xfrm>
+            <a:off x="3200400" y="2057400"/>
+            <a:ext cx="3200400" cy="502920"/>
+          </a:xfrm>
+          <a:prstGeom prst="roundRect">
+            <a:avLst>
+              <a:gd name="adj" fmla="val 14545"/>
+            </a:avLst>
+          </a:prstGeom>
+          <a:solidFill>
+            <a:srgbClr val="1E3A5F"/>
+          </a:solidFill>
+          <a:ln w="12700">
+            <a:solidFill>
+              <a:srgbClr val="028090"/>
+            </a:solidFill>
+            <a:prstDash val="solid"/>
+          </a:ln>
+        </p:spPr>
+      </p:sp>
+      <p:sp>
+        <p:nvSpPr>
+          <p:cNvPr id="10" name="Text 8"/>
+          <p:cNvSpPr/>
+          <p:nvPr/>
+        </p:nvSpPr>
+        <p:spPr>
+          <a:xfrm>
+            <a:off x="3200400" y="2057400"/>
+            <a:ext cx="3200400" cy="502920"/>
+          </a:xfrm>
+          <a:prstGeom prst="rect">
+            <a:avLst/>
+          </a:prstGeom>
+          <a:noFill/>
+          <a:ln/>
+        </p:spPr>
+        <p:txBody>
+          <a:bodyPr wrap="square" rtlCol="0" anchor="ctr"/>
+          <a:lstStyle/>
+          <a:p>
+            <a:pPr marL="0" indent="0" algn="ctr">
+              <a:buNone/>
+            </a:pPr>
+            <a:r>
+              <a:rPr lang="en-US" sz="1300" b="1" dirty="0">
+                <a:solidFill>
+                  <a:srgbClr val="FFFFFF"/>
+                </a:solidFill>
+                <a:latin typeface="Calibri" pitchFamily="34" charset="0"/>
+                <a:ea typeface="Calibri" pitchFamily="34" charset="-122"/>
+                <a:cs typeface="Calibri" pitchFamily="34" charset="-120"/>
+              </a:rPr>
+              <a:t>Similarity Score (</a:t>
+            </a:r>
+            <a:r>
+              <a:rPr lang="tr-TR" sz="1300" b="1" dirty="0">
+                <a:solidFill>
+                  <a:srgbClr val="FFFFFF"/>
+                </a:solidFill>
+                <a:latin typeface="Calibri" pitchFamily="34" charset="0"/>
+                <a:ea typeface="Calibri" pitchFamily="34" charset="-122"/>
+                <a:cs typeface="Calibri" pitchFamily="34" charset="-120"/>
+              </a:rPr>
+              <a:t>Sentence -Tranformers</a:t>
+            </a:r>
+            <a:r>
+              <a:rPr lang="en-US" sz="1300" b="1" dirty="0">
+                <a:solidFill>
+                  <a:srgbClr val="FFFFFF"/>
+                </a:solidFill>
+                <a:latin typeface="Calibri" pitchFamily="34" charset="0"/>
+                <a:ea typeface="Calibri" pitchFamily="34" charset="-122"/>
+                <a:cs typeface="Calibri" pitchFamily="34" charset="-120"/>
+              </a:rPr>
+              <a:t>)</a:t>
+            </a:r>
+            <a:endParaRPr lang="en-US" sz="1300" dirty="0"/>
+          </a:p>
+        </p:txBody>
+      </p:sp>
+      <p:sp>
+        <p:nvSpPr>
+          <p:cNvPr id="11" name="Text 9"/>
+          <p:cNvSpPr/>
+          <p:nvPr/>
+        </p:nvSpPr>
+        <p:spPr>
+          <a:xfrm>
+            <a:off x="3200400" y="2560320"/>
+            <a:ext cx="3200400" cy="320040"/>
+          </a:xfrm>
+          <a:prstGeom prst="rect">
+            <a:avLst/>
+          </a:prstGeom>
+          <a:noFill/>
+          <a:ln/>
+        </p:spPr>
+        <p:txBody>
+          <a:bodyPr wrap="square" rtlCol="0" anchor="ctr"/>
+          <a:lstStyle/>
+          <a:p>
+            <a:pPr marL="0" indent="0" algn="ctr">
+              <a:buNone/>
+            </a:pPr>
+            <a:r>
+              <a:rPr lang="en-US" sz="1600" dirty="0">
+                <a:solidFill>
+                  <a:srgbClr val="94A3B8"/>
+                </a:solidFill>
+              </a:rPr>
+              <a:t>↓</a:t>
+            </a:r>
+            <a:endParaRPr lang="en-US" sz="1600" dirty="0"/>
+          </a:p>
+        </p:txBody>
+      </p:sp>
+      <p:sp>
+        <p:nvSpPr>
+          <p:cNvPr id="12" name="Shape 10"/>
+          <p:cNvSpPr/>
+          <p:nvPr/>
+        </p:nvSpPr>
+        <p:spPr>
+          <a:xfrm>
+            <a:off x="182880" y="2880360"/>
+            <a:ext cx="2926080" cy="685800"/>
+          </a:xfrm>
+          <a:prstGeom prst="roundRect">
+            <a:avLst>
+              <a:gd name="adj" fmla="val 10667"/>
+            </a:avLst>
+          </a:prstGeom>
+          <a:solidFill>
+            <a:srgbClr val="C0392B"/>
+          </a:solidFill>
+          <a:ln w="12700">
+            <a:solidFill>
+              <a:srgbClr val="C0392B"/>
+            </a:solidFill>
+            <a:prstDash val="solid"/>
+          </a:ln>
+          <a:effectLst>
+            <a:outerShdw blurRad="101600" dist="38100" dir="2700000" algn="bl" rotWithShape="0">
+              <a:srgbClr val="000000">
+                <a:alpha val="12000"/>
+              </a:srgbClr>
+            </a:outerShdw>
+          </a:effectLst>
+        </p:spPr>
+      </p:sp>
+      <p:sp>
+        <p:nvSpPr>
+          <p:cNvPr id="13" name="Text 11"/>
+          <p:cNvSpPr/>
+          <p:nvPr/>
+        </p:nvSpPr>
+        <p:spPr>
+          <a:xfrm>
+            <a:off x="182880" y="2880360"/>
+            <a:ext cx="2926080" cy="685800"/>
+          </a:xfrm>
+          <a:prstGeom prst="rect">
+            <a:avLst/>
+          </a:prstGeom>
+          <a:noFill/>
+          <a:ln/>
+        </p:spPr>
+        <p:txBody>
+          <a:bodyPr wrap="square" rtlCol="0" anchor="ctr"/>
+          <a:lstStyle/>
+          <a:p>
+            <a:pPr marL="0" indent="0" algn="ctr">
+              <a:buNone/>
+            </a:pPr>
+            <a:r>
+              <a:rPr lang="en-US" sz="1100" b="1" dirty="0">
+                <a:solidFill>
+                  <a:srgbClr val="FFFFFF"/>
+                </a:solidFill>
+                <a:latin typeface="Calibri" pitchFamily="34" charset="0"/>
+                <a:ea typeface="Calibri" pitchFamily="34" charset="-122"/>
+                <a:cs typeface="Calibri" pitchFamily="34" charset="-120"/>
+              </a:rPr>
+              <a:t>Score &gt; Delete</a:t>
+            </a:r>
+            <a:endParaRPr lang="en-US" sz="1100" dirty="0"/>
+          </a:p>
+          <a:p>
+            <a:pPr marL="0" indent="0" algn="ctr">
+              <a:buNone/>
+            </a:pPr>
+            <a:r>
+              <a:rPr lang="en-US" sz="1100" b="1" dirty="0">
+                <a:solidFill>
+                  <a:srgbClr val="FFFFFF"/>
+                </a:solidFill>
+                <a:latin typeface="Calibri" pitchFamily="34" charset="0"/>
+                <a:ea typeface="Calibri" pitchFamily="34" charset="-122"/>
+                <a:cs typeface="Calibri" pitchFamily="34" charset="-120"/>
+              </a:rPr>
+              <a:t>Threshold</a:t>
+            </a:r>
+            <a:endParaRPr lang="en-US" sz="1100" dirty="0"/>
+          </a:p>
+        </p:txBody>
+      </p:sp>
+      <p:sp>
+        <p:nvSpPr>
+          <p:cNvPr id="14" name="Text 12"/>
+          <p:cNvSpPr/>
+          <p:nvPr/>
+        </p:nvSpPr>
+        <p:spPr>
+          <a:xfrm>
+            <a:off x="182880" y="3566160"/>
+            <a:ext cx="2926080" cy="320040"/>
+          </a:xfrm>
+          <a:prstGeom prst="rect">
+            <a:avLst/>
+          </a:prstGeom>
+          <a:noFill/>
+          <a:ln/>
+        </p:spPr>
+        <p:txBody>
+          <a:bodyPr wrap="square" rtlCol="0" anchor="ctr"/>
+          <a:lstStyle/>
+          <a:p>
+            <a:pPr marL="0" indent="0" algn="ctr">
+              <a:buNone/>
+            </a:pPr>
+            <a:r>
+              <a:rPr lang="en-US" sz="1400" dirty="0">
+                <a:solidFill>
+                  <a:srgbClr val="94A3B8"/>
+                </a:solidFill>
+              </a:rPr>
+              <a:t>↓</a:t>
+            </a:r>
+            <a:endParaRPr lang="en-US" sz="1400" dirty="0"/>
+          </a:p>
+        </p:txBody>
+      </p:sp>
+      <p:sp>
+        <p:nvSpPr>
+          <p:cNvPr id="15" name="Shape 13"/>
+          <p:cNvSpPr/>
+          <p:nvPr/>
+        </p:nvSpPr>
+        <p:spPr>
+          <a:xfrm>
+            <a:off x="182880" y="3886200"/>
+            <a:ext cx="2926080" cy="594360"/>
+          </a:xfrm>
+          <a:prstGeom prst="roundRect">
+            <a:avLst>
+              <a:gd name="adj" fmla="val 12308"/>
+            </a:avLst>
+          </a:prstGeom>
+          <a:solidFill>
+            <a:srgbClr val="7F1D1D"/>
+          </a:solidFill>
+          <a:ln w="12700">
+            <a:solidFill>
+              <a:srgbClr val="C0392B"/>
+            </a:solidFill>
+            <a:prstDash val="solid"/>
+          </a:ln>
+        </p:spPr>
+        <p:txBody>
+          <a:bodyPr/>
+          <a:lstStyle/>
+          <a:p>
+            <a:endParaRPr lang="en-US" dirty="0"/>
+          </a:p>
+        </p:txBody>
+      </p:sp>
+      <p:sp>
+        <p:nvSpPr>
+          <p:cNvPr id="16" name="Text 14"/>
+          <p:cNvSpPr/>
+          <p:nvPr/>
+        </p:nvSpPr>
+        <p:spPr>
+          <a:xfrm>
+            <a:off x="182880" y="3886200"/>
+            <a:ext cx="2926080" cy="594360"/>
+          </a:xfrm>
+          <a:prstGeom prst="rect">
+            <a:avLst/>
+          </a:prstGeom>
+          <a:noFill/>
+          <a:ln/>
+        </p:spPr>
+        <p:txBody>
+          <a:bodyPr wrap="square" rtlCol="0" anchor="ctr"/>
+          <a:lstStyle/>
+          <a:p>
+            <a:pPr marL="0" indent="0" algn="ctr">
+              <a:buNone/>
+            </a:pPr>
+            <a:r>
+              <a:rPr lang="tr-TR" sz="1200" b="1" dirty="0">
+                <a:solidFill>
+                  <a:srgbClr val="02C39A"/>
+                </a:solidFill>
+                <a:latin typeface="Calibri" pitchFamily="34" charset="0"/>
+                <a:ea typeface="Calibri" pitchFamily="34" charset="-122"/>
+                <a:cs typeface="Calibri" pitchFamily="34" charset="-120"/>
+              </a:rPr>
+              <a:t>Let User choose what to keep</a:t>
+            </a:r>
+            <a:endParaRPr lang="en-US" sz="1200" dirty="0"/>
+          </a:p>
+        </p:txBody>
+      </p:sp>
+      <p:sp>
+        <p:nvSpPr>
+          <p:cNvPr id="17" name="Shape 15"/>
+          <p:cNvSpPr/>
+          <p:nvPr/>
+        </p:nvSpPr>
+        <p:spPr>
+          <a:xfrm>
+            <a:off x="3017520" y="2880360"/>
+            <a:ext cx="2926080" cy="685800"/>
+          </a:xfrm>
+          <a:prstGeom prst="roundRect">
+            <a:avLst>
+              <a:gd name="adj" fmla="val 10667"/>
+            </a:avLst>
+          </a:prstGeom>
+          <a:solidFill>
+            <a:srgbClr val="92400E"/>
+          </a:solidFill>
+          <a:ln w="12700">
+            <a:solidFill>
+              <a:srgbClr val="92400E"/>
+            </a:solidFill>
+            <a:prstDash val="solid"/>
+          </a:ln>
+          <a:effectLst>
+            <a:outerShdw blurRad="101600" dist="38100" dir="2700000" algn="bl" rotWithShape="0">
+              <a:srgbClr val="000000">
+                <a:alpha val="12000"/>
+              </a:srgbClr>
+            </a:outerShdw>
+          </a:effectLst>
+        </p:spPr>
+      </p:sp>
+      <p:sp>
+        <p:nvSpPr>
+          <p:cNvPr id="18" name="Text 16"/>
+          <p:cNvSpPr/>
+          <p:nvPr/>
+        </p:nvSpPr>
+        <p:spPr>
+          <a:xfrm>
+            <a:off x="3017520" y="2880360"/>
+            <a:ext cx="2926080" cy="685800"/>
+          </a:xfrm>
+          <a:prstGeom prst="rect">
+            <a:avLst/>
+          </a:prstGeom>
+          <a:noFill/>
+          <a:ln/>
+        </p:spPr>
+        <p:txBody>
+          <a:bodyPr wrap="square" rtlCol="0" anchor="ctr"/>
+          <a:lstStyle/>
+          <a:p>
+            <a:pPr marL="0" indent="0" algn="ctr">
+              <a:buNone/>
+            </a:pPr>
+            <a:r>
+              <a:rPr lang="en-US" sz="1100" b="1" dirty="0">
+                <a:solidFill>
+                  <a:srgbClr val="FFFFFF"/>
+                </a:solidFill>
+                <a:latin typeface="Calibri" pitchFamily="34" charset="0"/>
+                <a:ea typeface="Calibri" pitchFamily="34" charset="-122"/>
+                <a:cs typeface="Calibri" pitchFamily="34" charset="-120"/>
+              </a:rPr>
+              <a:t>Merge &lt; Score &lt;</a:t>
+            </a:r>
+            <a:endParaRPr lang="en-US" sz="1100" dirty="0"/>
+          </a:p>
+          <a:p>
+            <a:pPr marL="0" indent="0" algn="ctr">
+              <a:buNone/>
+            </a:pPr>
+            <a:r>
+              <a:rPr lang="en-US" sz="1100" b="1" dirty="0">
+                <a:solidFill>
+                  <a:srgbClr val="FFFFFF"/>
+                </a:solidFill>
+                <a:latin typeface="Calibri" pitchFamily="34" charset="0"/>
+                <a:ea typeface="Calibri" pitchFamily="34" charset="-122"/>
+                <a:cs typeface="Calibri" pitchFamily="34" charset="-120"/>
+              </a:rPr>
+              <a:t>Delete Threshold</a:t>
+            </a:r>
+            <a:endParaRPr lang="en-US" sz="1100" dirty="0"/>
+          </a:p>
+        </p:txBody>
+      </p:sp>
+      <p:sp>
+        <p:nvSpPr>
+          <p:cNvPr id="19" name="Text 17"/>
+          <p:cNvSpPr/>
+          <p:nvPr/>
+        </p:nvSpPr>
+        <p:spPr>
+          <a:xfrm>
+            <a:off x="3017520" y="3566160"/>
+            <a:ext cx="2926080" cy="320040"/>
+          </a:xfrm>
+          <a:prstGeom prst="rect">
+            <a:avLst/>
+          </a:prstGeom>
+          <a:noFill/>
+          <a:ln/>
+        </p:spPr>
+        <p:txBody>
+          <a:bodyPr wrap="square" rtlCol="0" anchor="ctr"/>
+          <a:lstStyle/>
+          <a:p>
+            <a:pPr marL="0" indent="0" algn="ctr">
+              <a:buNone/>
+            </a:pPr>
+            <a:r>
+              <a:rPr lang="en-US" sz="1400" dirty="0">
+                <a:solidFill>
+                  <a:srgbClr val="94A3B8"/>
+                </a:solidFill>
+              </a:rPr>
+              <a:t>↓</a:t>
+            </a:r>
+            <a:endParaRPr lang="en-US" sz="1400" dirty="0"/>
+          </a:p>
+        </p:txBody>
+      </p:sp>
+      <p:sp>
+        <p:nvSpPr>
+          <p:cNvPr id="20" name="Shape 18"/>
+          <p:cNvSpPr/>
+          <p:nvPr/>
+        </p:nvSpPr>
+        <p:spPr>
+          <a:xfrm>
+            <a:off x="3017520" y="3886200"/>
+            <a:ext cx="2926080" cy="594360"/>
+          </a:xfrm>
+          <a:prstGeom prst="roundRect">
+            <a:avLst>
+              <a:gd name="adj" fmla="val 12308"/>
+            </a:avLst>
+          </a:prstGeom>
+          <a:solidFill>
+            <a:srgbClr val="451A03"/>
+          </a:solidFill>
+          <a:ln w="12700">
+            <a:solidFill>
+              <a:srgbClr val="92400E"/>
+            </a:solidFill>
+            <a:prstDash val="solid"/>
+          </a:ln>
+        </p:spPr>
+      </p:sp>
+      <p:sp>
+        <p:nvSpPr>
+          <p:cNvPr id="21" name="Text 19"/>
+          <p:cNvSpPr/>
+          <p:nvPr/>
+        </p:nvSpPr>
+        <p:spPr>
+          <a:xfrm>
+            <a:off x="3017520" y="3886200"/>
+            <a:ext cx="2926080" cy="594360"/>
+          </a:xfrm>
+          <a:prstGeom prst="rect">
+            <a:avLst/>
+          </a:prstGeom>
+          <a:noFill/>
+          <a:ln/>
+        </p:spPr>
+        <p:txBody>
+          <a:bodyPr wrap="square" rtlCol="0" anchor="ctr"/>
+          <a:lstStyle/>
+          <a:p>
+            <a:pPr marL="0" indent="0" algn="ctr">
+              <a:buNone/>
+            </a:pPr>
+            <a:r>
+              <a:rPr lang="en-US" sz="1200" b="1" dirty="0">
+                <a:solidFill>
+                  <a:srgbClr val="02C39A"/>
+                </a:solidFill>
+                <a:latin typeface="Calibri" pitchFamily="34" charset="0"/>
+                <a:ea typeface="Calibri" pitchFamily="34" charset="-122"/>
+                <a:cs typeface="Calibri" pitchFamily="34" charset="-120"/>
+              </a:rPr>
+              <a:t>Send as Merge</a:t>
+            </a:r>
+            <a:endParaRPr lang="en-US" sz="1200" dirty="0"/>
+          </a:p>
+          <a:p>
+            <a:pPr marL="0" indent="0" algn="ctr">
+              <a:buNone/>
+            </a:pPr>
+            <a:r>
+              <a:rPr lang="en-US" sz="1200" b="1" dirty="0">
+                <a:solidFill>
+                  <a:srgbClr val="02C39A"/>
+                </a:solidFill>
+                <a:latin typeface="Calibri" pitchFamily="34" charset="0"/>
+                <a:ea typeface="Calibri" pitchFamily="34" charset="-122"/>
+                <a:cs typeface="Calibri" pitchFamily="34" charset="-120"/>
+              </a:rPr>
+              <a:t>Candidate</a:t>
+            </a:r>
+            <a:endParaRPr lang="en-US" sz="1200" dirty="0"/>
+          </a:p>
+        </p:txBody>
+      </p:sp>
+      <p:sp>
+        <p:nvSpPr>
+          <p:cNvPr id="22" name="Shape 20"/>
+          <p:cNvSpPr/>
+          <p:nvPr/>
+        </p:nvSpPr>
+        <p:spPr>
+          <a:xfrm>
+            <a:off x="5852160" y="2880360"/>
+            <a:ext cx="2926080" cy="685800"/>
+          </a:xfrm>
+          <a:prstGeom prst="roundRect">
+            <a:avLst>
+              <a:gd name="adj" fmla="val 10667"/>
+            </a:avLst>
+          </a:prstGeom>
+          <a:solidFill>
+            <a:srgbClr val="166534"/>
+          </a:solidFill>
+          <a:ln w="12700">
+            <a:solidFill>
+              <a:srgbClr val="166534"/>
+            </a:solidFill>
+            <a:prstDash val="solid"/>
+          </a:ln>
+          <a:effectLst>
+            <a:outerShdw blurRad="101600" dist="38100" dir="2700000" algn="bl" rotWithShape="0">
+              <a:srgbClr val="000000">
+                <a:alpha val="12000"/>
+              </a:srgbClr>
+            </a:outerShdw>
+          </a:effectLst>
+        </p:spPr>
+      </p:sp>
+      <p:sp>
+        <p:nvSpPr>
+          <p:cNvPr id="23" name="Text 21"/>
+          <p:cNvSpPr/>
+          <p:nvPr/>
+        </p:nvSpPr>
+        <p:spPr>
+          <a:xfrm>
+            <a:off x="5852160" y="2880360"/>
+            <a:ext cx="2926080" cy="685800"/>
+          </a:xfrm>
+          <a:prstGeom prst="rect">
+            <a:avLst/>
+          </a:prstGeom>
+          <a:noFill/>
+          <a:ln/>
+        </p:spPr>
+        <p:txBody>
+          <a:bodyPr wrap="square" rtlCol="0" anchor="ctr"/>
+          <a:lstStyle/>
+          <a:p>
+            <a:pPr marL="0" indent="0" algn="ctr">
+              <a:buNone/>
+            </a:pPr>
+            <a:r>
+              <a:rPr lang="en-US" sz="1100" b="1" dirty="0">
+                <a:solidFill>
+                  <a:srgbClr val="FFFFFF"/>
+                </a:solidFill>
+                <a:latin typeface="Calibri" pitchFamily="34" charset="0"/>
+                <a:ea typeface="Calibri" pitchFamily="34" charset="-122"/>
+                <a:cs typeface="Calibri" pitchFamily="34" charset="-120"/>
+              </a:rPr>
+              <a:t>Score &lt; Merge</a:t>
+            </a:r>
+            <a:endParaRPr lang="en-US" sz="1100" dirty="0"/>
+          </a:p>
+          <a:p>
+            <a:pPr marL="0" indent="0" algn="ctr">
+              <a:buNone/>
+            </a:pPr>
+            <a:r>
+              <a:rPr lang="en-US" sz="1100" b="1" dirty="0">
+                <a:solidFill>
+                  <a:srgbClr val="FFFFFF"/>
+                </a:solidFill>
+                <a:latin typeface="Calibri" pitchFamily="34" charset="0"/>
+                <a:ea typeface="Calibri" pitchFamily="34" charset="-122"/>
+                <a:cs typeface="Calibri" pitchFamily="34" charset="-120"/>
+              </a:rPr>
+              <a:t>Threshold</a:t>
+            </a:r>
+            <a:endParaRPr lang="en-US" sz="1100" dirty="0"/>
+          </a:p>
+        </p:txBody>
+      </p:sp>
+      <p:sp>
+        <p:nvSpPr>
+          <p:cNvPr id="24" name="Text 22"/>
+          <p:cNvSpPr/>
+          <p:nvPr/>
+        </p:nvSpPr>
+        <p:spPr>
+          <a:xfrm>
+            <a:off x="5852160" y="3566160"/>
+            <a:ext cx="2926080" cy="320040"/>
+          </a:xfrm>
+          <a:prstGeom prst="rect">
+            <a:avLst/>
+          </a:prstGeom>
+          <a:noFill/>
+          <a:ln/>
+        </p:spPr>
+        <p:txBody>
+          <a:bodyPr wrap="square" rtlCol="0" anchor="ctr"/>
+          <a:lstStyle/>
+          <a:p>
+            <a:pPr marL="0" indent="0" algn="ctr">
+              <a:buNone/>
+            </a:pPr>
+            <a:r>
+              <a:rPr lang="en-US" sz="1400" dirty="0">
+                <a:solidFill>
+                  <a:srgbClr val="94A3B8"/>
+                </a:solidFill>
+              </a:rPr>
+              <a:t>↓</a:t>
+            </a:r>
+            <a:endParaRPr lang="en-US" sz="1400" dirty="0"/>
+          </a:p>
+        </p:txBody>
+      </p:sp>
+      <p:sp>
+        <p:nvSpPr>
+          <p:cNvPr id="25" name="Shape 23"/>
+          <p:cNvSpPr/>
+          <p:nvPr/>
+        </p:nvSpPr>
+        <p:spPr>
+          <a:xfrm>
+            <a:off x="5852160" y="3886200"/>
+            <a:ext cx="2926080" cy="594360"/>
+          </a:xfrm>
+          <a:prstGeom prst="roundRect">
+            <a:avLst>
+              <a:gd name="adj" fmla="val 12308"/>
+            </a:avLst>
+          </a:prstGeom>
+          <a:solidFill>
+            <a:srgbClr val="052E16"/>
+          </a:solidFill>
+          <a:ln w="12700">
+            <a:solidFill>
+              <a:srgbClr val="166534"/>
+            </a:solidFill>
+            <a:prstDash val="solid"/>
+          </a:ln>
+        </p:spPr>
+      </p:sp>
+      <p:sp>
+        <p:nvSpPr>
+          <p:cNvPr id="26" name="Text 24"/>
+          <p:cNvSpPr/>
+          <p:nvPr/>
+        </p:nvSpPr>
+        <p:spPr>
+          <a:xfrm>
+            <a:off x="5852160" y="3886200"/>
+            <a:ext cx="2926080" cy="594360"/>
+          </a:xfrm>
+          <a:prstGeom prst="rect">
+            <a:avLst/>
+          </a:prstGeom>
+          <a:noFill/>
+          <a:ln/>
+        </p:spPr>
+        <p:txBody>
+          <a:bodyPr wrap="square" rtlCol="0" anchor="ctr"/>
+          <a:lstStyle/>
+          <a:p>
+            <a:pPr marL="0" indent="0" algn="ctr">
+              <a:buNone/>
+            </a:pPr>
+            <a:r>
+              <a:rPr lang="en-US" sz="1200" b="1" dirty="0">
+                <a:solidFill>
+                  <a:srgbClr val="02C39A"/>
+                </a:solidFill>
+                <a:latin typeface="Calibri" pitchFamily="34" charset="0"/>
+                <a:ea typeface="Calibri" pitchFamily="34" charset="-122"/>
+                <a:cs typeface="Calibri" pitchFamily="34" charset="-120"/>
+              </a:rPr>
+              <a:t>Keep Unchanged</a:t>
+            </a:r>
+            <a:endParaRPr lang="en-US" sz="1200" dirty="0"/>
+          </a:p>
+        </p:txBody>
+      </p:sp>
+    </p:spTree>
+  </p:cSld>
+  <p:clrMapOvr>
+    <a:masterClrMapping/>
+  </p:clrMapOvr>
+</p:sld>
+</file>
+
+<file path=ppt/slides/slide13.xml><?xml version="1.0" encoding="utf-8"?>
 <p:sld xmlns:a="http://schemas.openxmlformats.org/drawingml/2006/main" xmlns:r="http://schemas.openxmlformats.org/officeDocument/2006/relationships" xmlns:p="http://schemas.openxmlformats.org/presentationml/2006/main">
   <p:cSld>
     <p:bg>
@@ -2591,7 +4514,7 @@
                 <a:ea typeface="Cambria" pitchFamily="34" charset="-122"/>
                 <a:cs typeface="Cambria" pitchFamily="34" charset="-120"/>
               </a:rPr>
-              <a:t>Repetition</a:t>
+              <a:t>Re</a:t>
             </a:r>
             <a:r>
               <a:rPr lang="tr-TR" sz="3000" b="1" dirty="0">
@@ -2602,7 +4525,7 @@
                 <a:ea typeface="Cambria" pitchFamily="34" charset="-122"/>
                 <a:cs typeface="Cambria" pitchFamily="34" charset="-120"/>
               </a:rPr>
-              <a:t> And Pleonasm </a:t>
+              <a:t>dundant Pair </a:t>
             </a:r>
             <a:endParaRPr lang="en-US" sz="3000" dirty="0"/>
           </a:p>
@@ -2635,10 +4558,10 @@
       </p:sp>
       <p:pic>
         <p:nvPicPr>
-          <p:cNvPr id="5" name="Picture 4">
+          <p:cNvPr id="6" name="Picture 5">
             <a:extLst>
               <a:ext uri="{FF2B5EF4-FFF2-40B4-BE49-F238E27FC236}">
-                <a16:creationId xmlns:a16="http://schemas.microsoft.com/office/drawing/2014/main" id="{17AF872E-89CC-4A16-9D28-1FB2F1628204}"/>
+                <a16:creationId xmlns:a16="http://schemas.microsoft.com/office/drawing/2014/main" id="{7207D86A-6DCB-4055-93C1-4F3568E49109}"/>
               </a:ext>
             </a:extLst>
           </p:cNvPr>
@@ -2655,1949 +4578,20 @@
         </p:blipFill>
         <p:spPr>
           <a:xfrm>
-            <a:off x="661830" y="1541889"/>
-            <a:ext cx="7164922" cy="3177182"/>
+            <a:off x="385658" y="1514818"/>
+            <a:ext cx="8638056" cy="2732569"/>
           </a:xfrm>
           <a:prstGeom prst="rect">
             <a:avLst/>
           </a:prstGeom>
         </p:spPr>
       </p:pic>
-      <p:sp>
-        <p:nvSpPr>
-          <p:cNvPr id="8" name="TextBox 7">
-            <a:extLst>
-              <a:ext uri="{FF2B5EF4-FFF2-40B4-BE49-F238E27FC236}">
-                <a16:creationId xmlns:a16="http://schemas.microsoft.com/office/drawing/2014/main" id="{414C5294-55E2-4141-AC18-117A3DD939D3}"/>
-              </a:ext>
-            </a:extLst>
-          </p:cNvPr>
-          <p:cNvSpPr txBox="1"/>
-          <p:nvPr/>
-        </p:nvSpPr>
-        <p:spPr>
-          <a:xfrm>
-            <a:off x="661830" y="1080250"/>
-            <a:ext cx="7164921" cy="369332"/>
-          </a:xfrm>
-          <a:prstGeom prst="rect">
-            <a:avLst/>
-          </a:prstGeom>
-          <a:noFill/>
-        </p:spPr>
-        <p:txBody>
-          <a:bodyPr wrap="square">
-            <a:spAutoFit/>
-          </a:bodyPr>
-          <a:lstStyle/>
-          <a:p>
-            <a:r>
-              <a:rPr lang="tr-TR" dirty="0"/>
-              <a:t>Result of corrected format</a:t>
-            </a:r>
-            <a:endParaRPr lang="en-US" dirty="0"/>
-          </a:p>
-        </p:txBody>
-      </p:sp>
     </p:spTree>
     <p:extLst>
       <p:ext uri="{BB962C8B-B14F-4D97-AF65-F5344CB8AC3E}">
         <p14:creationId xmlns:p14="http://schemas.microsoft.com/office/powerpoint/2010/main" val="1350976747"/>
       </p:ext>
     </p:extLst>
-  </p:cSld>
-  <p:clrMapOvr>
-    <a:masterClrMapping/>
-  </p:clrMapOvr>
-</p:sld>
-</file>
-
-<file path=ppt/slides/slide12.xml><?xml version="1.0" encoding="utf-8"?>
-<p:sld xmlns:a="http://schemas.openxmlformats.org/drawingml/2006/main" xmlns:r="http://schemas.openxmlformats.org/officeDocument/2006/relationships" xmlns:p="http://schemas.openxmlformats.org/presentationml/2006/main">
-  <p:cSld name="Slide 10">
-    <p:bg>
-      <p:bgPr>
-        <a:solidFill>
-          <a:srgbClr val="F1F5F9"/>
-        </a:solidFill>
-        <a:effectLst/>
-      </p:bgPr>
-    </p:bg>
-    <p:spTree>
-      <p:nvGrpSpPr>
-        <p:cNvPr id="1" name=""/>
-        <p:cNvGrpSpPr/>
-        <p:nvPr/>
-      </p:nvGrpSpPr>
-      <p:grpSpPr>
-        <a:xfrm>
-          <a:off x="0" y="0"/>
-          <a:ext cx="0" cy="0"/>
-          <a:chOff x="0" y="0"/>
-          <a:chExt cx="0" cy="0"/>
-        </a:xfrm>
-      </p:grpSpPr>
-      <p:sp>
-        <p:nvSpPr>
-          <p:cNvPr id="2" name="Text 0"/>
-          <p:cNvSpPr/>
-          <p:nvPr/>
-        </p:nvSpPr>
-        <p:spPr>
-          <a:xfrm>
-            <a:off x="457200" y="256032"/>
-            <a:ext cx="8229600" cy="594360"/>
-          </a:xfrm>
-          <a:prstGeom prst="rect">
-            <a:avLst/>
-          </a:prstGeom>
-          <a:noFill/>
-          <a:ln/>
-        </p:spPr>
-        <p:txBody>
-          <a:bodyPr wrap="square" rtlCol="0" anchor="ctr"/>
-          <a:lstStyle/>
-          <a:p>
-            <a:pPr marL="0" indent="0">
-              <a:buNone/>
-            </a:pPr>
-            <a:r>
-              <a:rPr lang="en-US" sz="3000" b="1" dirty="0">
-                <a:solidFill>
-                  <a:srgbClr val="0D2137"/>
-                </a:solidFill>
-                <a:latin typeface="Cambria" pitchFamily="34" charset="0"/>
-                <a:ea typeface="Cambria" pitchFamily="34" charset="-122"/>
-                <a:cs typeface="Cambria" pitchFamily="34" charset="-120"/>
-              </a:rPr>
-              <a:t>Redundancy Detection</a:t>
-            </a:r>
-            <a:endParaRPr lang="en-US" sz="3000" dirty="0"/>
-          </a:p>
-        </p:txBody>
-      </p:sp>
-      <p:sp>
-        <p:nvSpPr>
-          <p:cNvPr id="3" name="Shape 1"/>
-          <p:cNvSpPr/>
-          <p:nvPr/>
-        </p:nvSpPr>
-        <p:spPr>
-          <a:xfrm>
-            <a:off x="457200" y="868680"/>
-            <a:ext cx="8229600" cy="27432"/>
-          </a:xfrm>
-          <a:prstGeom prst="rect">
-            <a:avLst/>
-          </a:prstGeom>
-          <a:solidFill>
-            <a:srgbClr val="028090"/>
-          </a:solidFill>
-          <a:ln w="12700">
-            <a:solidFill>
-              <a:srgbClr val="028090"/>
-            </a:solidFill>
-            <a:prstDash val="solid"/>
-          </a:ln>
-        </p:spPr>
-      </p:sp>
-      <p:sp>
-        <p:nvSpPr>
-          <p:cNvPr id="4" name="Text 2"/>
-          <p:cNvSpPr/>
-          <p:nvPr/>
-        </p:nvSpPr>
-        <p:spPr>
-          <a:xfrm>
-            <a:off x="457200" y="1051560"/>
-            <a:ext cx="4023360" cy="411480"/>
-          </a:xfrm>
-          <a:prstGeom prst="rect">
-            <a:avLst/>
-          </a:prstGeom>
-          <a:noFill/>
-          <a:ln/>
-        </p:spPr>
-        <p:txBody>
-          <a:bodyPr wrap="square" rtlCol="0" anchor="ctr"/>
-          <a:lstStyle/>
-          <a:p>
-            <a:pPr marL="0" indent="0">
-              <a:buNone/>
-            </a:pPr>
-            <a:r>
-              <a:rPr lang="en-US" sz="1700" b="1" dirty="0">
-                <a:solidFill>
-                  <a:srgbClr val="028090"/>
-                </a:solidFill>
-                <a:latin typeface="Cambria" pitchFamily="34" charset="0"/>
-                <a:ea typeface="Cambria" pitchFamily="34" charset="-122"/>
-                <a:cs typeface="Cambria" pitchFamily="34" charset="-120"/>
-              </a:rPr>
-              <a:t>Semantic Similarity Analysis</a:t>
-            </a:r>
-            <a:endParaRPr lang="en-US" sz="1700" dirty="0"/>
-          </a:p>
-        </p:txBody>
-      </p:sp>
-      <p:sp>
-        <p:nvSpPr>
-          <p:cNvPr id="6" name="Shape 4"/>
-          <p:cNvSpPr/>
-          <p:nvPr/>
-        </p:nvSpPr>
-        <p:spPr>
-          <a:xfrm>
-            <a:off x="365760" y="2852928"/>
-            <a:ext cx="4023360" cy="640080"/>
-          </a:xfrm>
-          <a:prstGeom prst="roundRect">
-            <a:avLst>
-              <a:gd name="adj" fmla="val 10000"/>
-            </a:avLst>
-          </a:prstGeom>
-          <a:solidFill>
-            <a:srgbClr val="EFF6FF"/>
-          </a:solidFill>
-          <a:ln w="12700">
-            <a:solidFill>
-              <a:srgbClr val="BFDBFE"/>
-            </a:solidFill>
-            <a:prstDash val="solid"/>
-          </a:ln>
-          <a:effectLst>
-            <a:outerShdw blurRad="101600" dist="38100" dir="2700000" algn="bl" rotWithShape="0">
-              <a:srgbClr val="000000">
-                <a:alpha val="12000"/>
-              </a:srgbClr>
-            </a:outerShdw>
-          </a:effectLst>
-        </p:spPr>
-      </p:sp>
-      <p:sp>
-        <p:nvSpPr>
-          <p:cNvPr id="7" name="Text 5"/>
-          <p:cNvSpPr/>
-          <p:nvPr/>
-        </p:nvSpPr>
-        <p:spPr>
-          <a:xfrm>
-            <a:off x="548640" y="2880360"/>
-            <a:ext cx="3657600" cy="274320"/>
-          </a:xfrm>
-          <a:prstGeom prst="rect">
-            <a:avLst/>
-          </a:prstGeom>
-          <a:noFill/>
-          <a:ln/>
-        </p:spPr>
-        <p:txBody>
-          <a:bodyPr wrap="square" rtlCol="0" anchor="ctr"/>
-          <a:lstStyle/>
-          <a:p>
-            <a:pPr marL="0" indent="0">
-              <a:buNone/>
-            </a:pPr>
-            <a:r>
-              <a:rPr lang="en-US" sz="1400" dirty="0">
-                <a:solidFill>
-                  <a:srgbClr val="0070C0"/>
-                </a:solidFill>
-              </a:rPr>
-              <a:t>Sentence-Transformer Embeddings</a:t>
-            </a:r>
-            <a:endParaRPr lang="en-US" sz="1300" dirty="0">
-              <a:solidFill>
-                <a:srgbClr val="0070C0"/>
-              </a:solidFill>
-            </a:endParaRPr>
-          </a:p>
-        </p:txBody>
-      </p:sp>
-      <p:sp>
-        <p:nvSpPr>
-          <p:cNvPr id="8" name="Text 6"/>
-          <p:cNvSpPr/>
-          <p:nvPr/>
-        </p:nvSpPr>
-        <p:spPr>
-          <a:xfrm>
-            <a:off x="548640" y="3154680"/>
-            <a:ext cx="3657600" cy="274320"/>
-          </a:xfrm>
-          <a:prstGeom prst="rect">
-            <a:avLst/>
-          </a:prstGeom>
-          <a:noFill/>
-          <a:ln/>
-        </p:spPr>
-        <p:txBody>
-          <a:bodyPr wrap="square" rtlCol="0" anchor="ctr"/>
-          <a:lstStyle/>
-          <a:p>
-            <a:pPr marL="0" indent="0">
-              <a:buNone/>
-            </a:pPr>
-            <a:r>
-              <a:rPr lang="tr-TR" sz="1100" dirty="0">
-                <a:solidFill>
-                  <a:srgbClr val="64748B"/>
-                </a:solidFill>
-                <a:latin typeface="Calibri" pitchFamily="34" charset="0"/>
-                <a:ea typeface="Calibri" pitchFamily="34" charset="-122"/>
-                <a:cs typeface="Calibri" pitchFamily="34" charset="-120"/>
-              </a:rPr>
-              <a:t>Multilingual semantic sentence vectors</a:t>
-            </a:r>
-            <a:endParaRPr lang="en-US" sz="1100" dirty="0"/>
-          </a:p>
-        </p:txBody>
-      </p:sp>
-      <p:sp>
-        <p:nvSpPr>
-          <p:cNvPr id="9" name="Shape 7"/>
-          <p:cNvSpPr/>
-          <p:nvPr/>
-        </p:nvSpPr>
-        <p:spPr>
-          <a:xfrm>
-            <a:off x="365760" y="3602736"/>
-            <a:ext cx="4023360" cy="640080"/>
-          </a:xfrm>
-          <a:prstGeom prst="roundRect">
-            <a:avLst>
-              <a:gd name="adj" fmla="val 10000"/>
-            </a:avLst>
-          </a:prstGeom>
-          <a:solidFill>
-            <a:srgbClr val="EFF6FF"/>
-          </a:solidFill>
-          <a:ln w="12700">
-            <a:solidFill>
-              <a:srgbClr val="BFDBFE"/>
-            </a:solidFill>
-            <a:prstDash val="solid"/>
-          </a:ln>
-          <a:effectLst>
-            <a:outerShdw blurRad="101600" dist="38100" dir="2700000" algn="bl" rotWithShape="0">
-              <a:srgbClr val="000000">
-                <a:alpha val="12000"/>
-              </a:srgbClr>
-            </a:outerShdw>
-          </a:effectLst>
-        </p:spPr>
-      </p:sp>
-      <p:sp>
-        <p:nvSpPr>
-          <p:cNvPr id="10" name="Text 8"/>
-          <p:cNvSpPr/>
-          <p:nvPr/>
-        </p:nvSpPr>
-        <p:spPr>
-          <a:xfrm>
-            <a:off x="548640" y="3630168"/>
-            <a:ext cx="3657600" cy="274320"/>
-          </a:xfrm>
-          <a:prstGeom prst="rect">
-            <a:avLst/>
-          </a:prstGeom>
-          <a:noFill/>
-          <a:ln/>
-        </p:spPr>
-        <p:txBody>
-          <a:bodyPr wrap="square" rtlCol="0" anchor="ctr"/>
-          <a:lstStyle/>
-          <a:p>
-            <a:pPr marL="0" indent="0">
-              <a:buNone/>
-            </a:pPr>
-            <a:r>
-              <a:rPr lang="tr-TR" sz="1300" b="1" dirty="0">
-                <a:solidFill>
-                  <a:srgbClr val="0070C0"/>
-                </a:solidFill>
-                <a:latin typeface="Cambria" pitchFamily="34" charset="0"/>
-                <a:ea typeface="Cambria" pitchFamily="34" charset="-122"/>
-              </a:rPr>
-              <a:t>Cosine Similarity Matrix</a:t>
-            </a:r>
-            <a:endParaRPr lang="en-US" sz="1300" dirty="0">
-              <a:solidFill>
-                <a:srgbClr val="0070C0"/>
-              </a:solidFill>
-            </a:endParaRPr>
-          </a:p>
-        </p:txBody>
-      </p:sp>
-      <p:sp>
-        <p:nvSpPr>
-          <p:cNvPr id="11" name="Text 9"/>
-          <p:cNvSpPr/>
-          <p:nvPr/>
-        </p:nvSpPr>
-        <p:spPr>
-          <a:xfrm>
-            <a:off x="548640" y="3904488"/>
-            <a:ext cx="3657600" cy="274320"/>
-          </a:xfrm>
-          <a:prstGeom prst="rect">
-            <a:avLst/>
-          </a:prstGeom>
-          <a:noFill/>
-          <a:ln/>
-        </p:spPr>
-        <p:txBody>
-          <a:bodyPr wrap="square" rtlCol="0" anchor="ctr"/>
-          <a:lstStyle/>
-          <a:p>
-            <a:pPr marL="0" indent="0">
-              <a:buNone/>
-            </a:pPr>
-            <a:r>
-              <a:rPr lang="tr-TR" sz="1100" dirty="0">
-                <a:solidFill>
-                  <a:srgbClr val="64748B"/>
-                </a:solidFill>
-                <a:latin typeface="Calibri" pitchFamily="34" charset="0"/>
-                <a:ea typeface="Calibri" pitchFamily="34" charset="-122"/>
-                <a:cs typeface="Calibri" pitchFamily="34" charset="-120"/>
-              </a:rPr>
-              <a:t>Compares every sentence pair</a:t>
-            </a:r>
-            <a:endParaRPr lang="en-US" sz="1100" dirty="0"/>
-          </a:p>
-        </p:txBody>
-      </p:sp>
-      <p:sp>
-        <p:nvSpPr>
-          <p:cNvPr id="12" name="Shape 10"/>
-          <p:cNvSpPr/>
-          <p:nvPr/>
-        </p:nvSpPr>
-        <p:spPr>
-          <a:xfrm>
-            <a:off x="365760" y="4379976"/>
-            <a:ext cx="4023360" cy="640080"/>
-          </a:xfrm>
-          <a:prstGeom prst="roundRect">
-            <a:avLst>
-              <a:gd name="adj" fmla="val 10000"/>
-            </a:avLst>
-          </a:prstGeom>
-          <a:solidFill>
-            <a:srgbClr val="EFF6FF"/>
-          </a:solidFill>
-          <a:ln w="12700">
-            <a:solidFill>
-              <a:srgbClr val="BFDBFE"/>
-            </a:solidFill>
-            <a:prstDash val="solid"/>
-          </a:ln>
-          <a:effectLst>
-            <a:outerShdw blurRad="101600" dist="38100" dir="2700000" algn="bl" rotWithShape="0">
-              <a:srgbClr val="000000">
-                <a:alpha val="12000"/>
-              </a:srgbClr>
-            </a:outerShdw>
-          </a:effectLst>
-        </p:spPr>
-      </p:sp>
-      <p:sp>
-        <p:nvSpPr>
-          <p:cNvPr id="13" name="Text 11"/>
-          <p:cNvSpPr/>
-          <p:nvPr/>
-        </p:nvSpPr>
-        <p:spPr>
-          <a:xfrm>
-            <a:off x="548640" y="4379976"/>
-            <a:ext cx="3657600" cy="274320"/>
-          </a:xfrm>
-          <a:prstGeom prst="rect">
-            <a:avLst/>
-          </a:prstGeom>
-          <a:noFill/>
-          <a:ln/>
-        </p:spPr>
-        <p:txBody>
-          <a:bodyPr wrap="square" rtlCol="0" anchor="ctr"/>
-          <a:lstStyle/>
-          <a:p>
-            <a:pPr marL="0" indent="0">
-              <a:buNone/>
-            </a:pPr>
-            <a:r>
-              <a:rPr lang="en-US" sz="1300" b="1" dirty="0">
-                <a:solidFill>
-                  <a:srgbClr val="0070C0"/>
-                </a:solidFill>
-                <a:latin typeface="Cambria" pitchFamily="34" charset="0"/>
-                <a:ea typeface="Cambria" pitchFamily="34" charset="-122"/>
-                <a:cs typeface="Cambria" pitchFamily="34" charset="-120"/>
-              </a:rPr>
-              <a:t>Threshold</a:t>
-            </a:r>
-            <a:r>
-              <a:rPr lang="tr-TR" sz="1300" b="1" dirty="0">
-                <a:solidFill>
-                  <a:srgbClr val="0070C0"/>
-                </a:solidFill>
-                <a:latin typeface="Cambria" pitchFamily="34" charset="0"/>
-                <a:ea typeface="Cambria" pitchFamily="34" charset="-122"/>
-                <a:cs typeface="Cambria" pitchFamily="34" charset="-120"/>
-              </a:rPr>
-              <a:t> Classification</a:t>
-            </a:r>
-            <a:endParaRPr lang="en-US" sz="1300" dirty="0">
-              <a:solidFill>
-                <a:srgbClr val="0070C0"/>
-              </a:solidFill>
-            </a:endParaRPr>
-          </a:p>
-        </p:txBody>
-      </p:sp>
-      <p:sp>
-        <p:nvSpPr>
-          <p:cNvPr id="14" name="Text 12"/>
-          <p:cNvSpPr/>
-          <p:nvPr/>
-        </p:nvSpPr>
-        <p:spPr>
-          <a:xfrm>
-            <a:off x="548640" y="4654296"/>
-            <a:ext cx="3657600" cy="274320"/>
-          </a:xfrm>
-          <a:prstGeom prst="rect">
-            <a:avLst/>
-          </a:prstGeom>
-          <a:noFill/>
-          <a:ln/>
-        </p:spPr>
-        <p:txBody>
-          <a:bodyPr wrap="square" rtlCol="0" anchor="ctr"/>
-          <a:lstStyle/>
-          <a:p>
-            <a:pPr marL="0" indent="0">
-              <a:buNone/>
-            </a:pPr>
-            <a:r>
-              <a:rPr lang="tr-TR" sz="1100" dirty="0">
-                <a:solidFill>
-                  <a:srgbClr val="64748B"/>
-                </a:solidFill>
-                <a:latin typeface="Calibri" pitchFamily="34" charset="0"/>
-                <a:ea typeface="Calibri" pitchFamily="34" charset="-122"/>
-                <a:cs typeface="Calibri" pitchFamily="34" charset="-120"/>
-              </a:rPr>
-              <a:t>Merge Candidate/ Manual Review</a:t>
-            </a:r>
-            <a:endParaRPr lang="en-US" sz="1100" dirty="0"/>
-          </a:p>
-        </p:txBody>
-      </p:sp>
-      <p:sp>
-        <p:nvSpPr>
-          <p:cNvPr id="15" name="Shape 13"/>
-          <p:cNvSpPr/>
-          <p:nvPr/>
-        </p:nvSpPr>
-        <p:spPr>
-          <a:xfrm>
-            <a:off x="4709160" y="1271016"/>
-            <a:ext cx="4023360" cy="3749040"/>
-          </a:xfrm>
-          <a:prstGeom prst="roundRect">
-            <a:avLst>
-              <a:gd name="adj" fmla="val 2439"/>
-            </a:avLst>
-          </a:prstGeom>
-          <a:solidFill>
-            <a:srgbClr val="FFFFFF"/>
-          </a:solidFill>
-          <a:ln w="12700">
-            <a:solidFill>
-              <a:srgbClr val="E2E8F0"/>
-            </a:solidFill>
-            <a:prstDash val="solid"/>
-          </a:ln>
-          <a:effectLst>
-            <a:outerShdw blurRad="101600" dist="38100" dir="2700000" algn="bl" rotWithShape="0">
-              <a:srgbClr val="000000">
-                <a:alpha val="12000"/>
-              </a:srgbClr>
-            </a:outerShdw>
-          </a:effectLst>
-        </p:spPr>
-      </p:sp>
-      <p:sp>
-        <p:nvSpPr>
-          <p:cNvPr id="16" name="Text 14"/>
-          <p:cNvSpPr/>
-          <p:nvPr/>
-        </p:nvSpPr>
-        <p:spPr>
-          <a:xfrm>
-            <a:off x="4937760" y="1417320"/>
-            <a:ext cx="3657600" cy="365760"/>
-          </a:xfrm>
-          <a:prstGeom prst="rect">
-            <a:avLst/>
-          </a:prstGeom>
-          <a:noFill/>
-          <a:ln/>
-        </p:spPr>
-        <p:txBody>
-          <a:bodyPr wrap="square" rtlCol="0" anchor="ctr"/>
-          <a:lstStyle/>
-          <a:p>
-            <a:pPr marL="0" indent="0">
-              <a:buNone/>
-            </a:pPr>
-            <a:r>
-              <a:rPr lang="en-US" sz="1500" b="1" dirty="0">
-                <a:solidFill>
-                  <a:srgbClr val="028090"/>
-                </a:solidFill>
-                <a:latin typeface="Cambria" pitchFamily="34" charset="0"/>
-                <a:ea typeface="Cambria" pitchFamily="34" charset="-122"/>
-                <a:cs typeface="Cambria" pitchFamily="34" charset="-120"/>
-              </a:rPr>
-              <a:t>Example</a:t>
-            </a:r>
-            <a:endParaRPr lang="en-US" sz="1500" dirty="0"/>
-          </a:p>
-        </p:txBody>
-      </p:sp>
-      <p:sp>
-        <p:nvSpPr>
-          <p:cNvPr id="17" name="Shape 15"/>
-          <p:cNvSpPr/>
-          <p:nvPr/>
-        </p:nvSpPr>
-        <p:spPr>
-          <a:xfrm>
-            <a:off x="4937760" y="1856232"/>
-            <a:ext cx="3566160" cy="594360"/>
-          </a:xfrm>
-          <a:prstGeom prst="roundRect">
-            <a:avLst>
-              <a:gd name="adj" fmla="val 9231"/>
-            </a:avLst>
-          </a:prstGeom>
-          <a:solidFill>
-            <a:srgbClr val="0F172A"/>
-          </a:solidFill>
-          <a:ln w="12700">
-            <a:solidFill>
-              <a:srgbClr val="1E3A5F"/>
-            </a:solidFill>
-            <a:prstDash val="solid"/>
-          </a:ln>
-        </p:spPr>
-      </p:sp>
-      <p:sp>
-        <p:nvSpPr>
-          <p:cNvPr id="18" name="Text 16"/>
-          <p:cNvSpPr/>
-          <p:nvPr/>
-        </p:nvSpPr>
-        <p:spPr>
-          <a:xfrm>
-            <a:off x="5029200" y="1856232"/>
-            <a:ext cx="3383280" cy="594360"/>
-          </a:xfrm>
-          <a:prstGeom prst="rect">
-            <a:avLst/>
-          </a:prstGeom>
-          <a:noFill/>
-          <a:ln/>
-        </p:spPr>
-        <p:txBody>
-          <a:bodyPr wrap="square" rtlCol="0" anchor="ctr"/>
-          <a:lstStyle/>
-          <a:p>
-            <a:pPr marL="0" indent="0">
-              <a:buNone/>
-            </a:pPr>
-            <a:r>
-              <a:rPr lang="en-US" sz="1100" i="1" dirty="0">
-                <a:solidFill>
-                  <a:srgbClr val="FCA5A5"/>
-                </a:solidFill>
-                <a:latin typeface="Courier New" pitchFamily="34" charset="0"/>
-                <a:ea typeface="Courier New" pitchFamily="34" charset="-122"/>
-                <a:cs typeface="Courier New" pitchFamily="34" charset="-120"/>
-              </a:rPr>
-              <a:t>Le vendite sono diminuite nel terzo trimestre.</a:t>
-            </a:r>
-            <a:endParaRPr lang="en-US" sz="1100" dirty="0"/>
-          </a:p>
-        </p:txBody>
-      </p:sp>
-      <p:sp>
-        <p:nvSpPr>
-          <p:cNvPr id="19" name="Text 17"/>
-          <p:cNvSpPr/>
-          <p:nvPr/>
-        </p:nvSpPr>
-        <p:spPr>
-          <a:xfrm>
-            <a:off x="4937760" y="2514600"/>
-            <a:ext cx="3566160" cy="274320"/>
-          </a:xfrm>
-          <a:prstGeom prst="rect">
-            <a:avLst/>
-          </a:prstGeom>
-          <a:noFill/>
-          <a:ln/>
-        </p:spPr>
-        <p:txBody>
-          <a:bodyPr wrap="square" rtlCol="0" anchor="ctr"/>
-          <a:lstStyle/>
-          <a:p>
-            <a:pPr marL="0" indent="0" algn="ctr">
-              <a:buNone/>
-            </a:pPr>
-            <a:r>
-              <a:rPr lang="en-US" sz="900" b="1" kern="0" spc="200" dirty="0">
-                <a:solidFill>
-                  <a:srgbClr val="92400E"/>
-                </a:solidFill>
-                <a:latin typeface="Calibri" pitchFamily="34" charset="0"/>
-                <a:ea typeface="Calibri" pitchFamily="34" charset="-122"/>
-                <a:cs typeface="Calibri" pitchFamily="34" charset="-120"/>
-              </a:rPr>
-              <a:t>SIMILAR MEANING</a:t>
-            </a:r>
-            <a:endParaRPr lang="en-US" sz="900" dirty="0"/>
-          </a:p>
-        </p:txBody>
-      </p:sp>
-      <p:sp>
-        <p:nvSpPr>
-          <p:cNvPr id="20" name="Shape 18"/>
-          <p:cNvSpPr/>
-          <p:nvPr/>
-        </p:nvSpPr>
-        <p:spPr>
-          <a:xfrm>
-            <a:off x="4937760" y="2807208"/>
-            <a:ext cx="3566160" cy="594360"/>
-          </a:xfrm>
-          <a:prstGeom prst="roundRect">
-            <a:avLst>
-              <a:gd name="adj" fmla="val 9231"/>
-            </a:avLst>
-          </a:prstGeom>
-          <a:solidFill>
-            <a:srgbClr val="0F172A"/>
-          </a:solidFill>
-          <a:ln w="12700">
-            <a:solidFill>
-              <a:srgbClr val="1E3A5F"/>
-            </a:solidFill>
-            <a:prstDash val="solid"/>
-          </a:ln>
-        </p:spPr>
-      </p:sp>
-      <p:sp>
-        <p:nvSpPr>
-          <p:cNvPr id="21" name="Text 19"/>
-          <p:cNvSpPr/>
-          <p:nvPr/>
-        </p:nvSpPr>
-        <p:spPr>
-          <a:xfrm>
-            <a:off x="5029200" y="2807208"/>
-            <a:ext cx="3383280" cy="594360"/>
-          </a:xfrm>
-          <a:prstGeom prst="rect">
-            <a:avLst/>
-          </a:prstGeom>
-          <a:noFill/>
-          <a:ln/>
-        </p:spPr>
-        <p:txBody>
-          <a:bodyPr wrap="square" rtlCol="0" anchor="ctr"/>
-          <a:lstStyle/>
-          <a:p>
-            <a:pPr marL="0" indent="0">
-              <a:buNone/>
-            </a:pPr>
-            <a:r>
-              <a:rPr lang="en-US" sz="1100" i="1" dirty="0">
-                <a:solidFill>
-                  <a:srgbClr val="FCA5A5"/>
-                </a:solidFill>
-                <a:latin typeface="Courier New" pitchFamily="34" charset="0"/>
-                <a:ea typeface="Courier New" pitchFamily="34" charset="-122"/>
-                <a:cs typeface="Courier New" pitchFamily="34" charset="-120"/>
-              </a:rPr>
-              <a:t>Nel terzo trimestre le vendite hanno registrato un calo.</a:t>
-            </a:r>
-            <a:endParaRPr lang="en-US" sz="1100" dirty="0"/>
-          </a:p>
-        </p:txBody>
-      </p:sp>
-      <p:sp>
-        <p:nvSpPr>
-          <p:cNvPr id="22" name="Shape 20"/>
-          <p:cNvSpPr/>
-          <p:nvPr/>
-        </p:nvSpPr>
-        <p:spPr>
-          <a:xfrm>
-            <a:off x="4937760" y="3520440"/>
-            <a:ext cx="3566160" cy="457200"/>
-          </a:xfrm>
-          <a:prstGeom prst="roundRect">
-            <a:avLst>
-              <a:gd name="adj" fmla="val 12000"/>
-            </a:avLst>
-          </a:prstGeom>
-          <a:solidFill>
-            <a:srgbClr val="FFFBEB"/>
-          </a:solidFill>
-          <a:ln w="12700">
-            <a:solidFill>
-              <a:srgbClr val="FDE68A"/>
-            </a:solidFill>
-            <a:prstDash val="solid"/>
-          </a:ln>
-        </p:spPr>
-      </p:sp>
-      <p:sp>
-        <p:nvSpPr>
-          <p:cNvPr id="23" name="Text 21"/>
-          <p:cNvSpPr/>
-          <p:nvPr/>
-        </p:nvSpPr>
-        <p:spPr>
-          <a:xfrm>
-            <a:off x="5029200" y="3538728"/>
-            <a:ext cx="3383280" cy="246888"/>
-          </a:xfrm>
-          <a:prstGeom prst="rect">
-            <a:avLst/>
-          </a:prstGeom>
-          <a:noFill/>
-          <a:ln/>
-        </p:spPr>
-        <p:txBody>
-          <a:bodyPr wrap="square" rtlCol="0" anchor="ctr"/>
-          <a:lstStyle/>
-          <a:p>
-            <a:pPr marL="0" indent="0">
-              <a:buNone/>
-            </a:pPr>
-            <a:r>
-              <a:rPr lang="en-US" sz="1200" b="1" dirty="0">
-                <a:solidFill>
-                  <a:srgbClr val="92400E"/>
-                </a:solidFill>
-                <a:latin typeface="Courier New" pitchFamily="34" charset="0"/>
-                <a:ea typeface="Courier New" pitchFamily="34" charset="-122"/>
-                <a:cs typeface="Courier New" pitchFamily="34" charset="-120"/>
-              </a:rPr>
-              <a:t>Similarity &gt; threshold</a:t>
-            </a:r>
-            <a:endParaRPr lang="en-US" sz="1200" dirty="0"/>
-          </a:p>
-        </p:txBody>
-      </p:sp>
-      <p:sp>
-        <p:nvSpPr>
-          <p:cNvPr id="24" name="Text 22"/>
-          <p:cNvSpPr/>
-          <p:nvPr/>
-        </p:nvSpPr>
-        <p:spPr>
-          <a:xfrm>
-            <a:off x="5029200" y="3776472"/>
-            <a:ext cx="3383280" cy="201168"/>
-          </a:xfrm>
-          <a:prstGeom prst="rect">
-            <a:avLst/>
-          </a:prstGeom>
-          <a:noFill/>
-          <a:ln/>
-        </p:spPr>
-        <p:txBody>
-          <a:bodyPr wrap="square" rtlCol="0" anchor="ctr"/>
-          <a:lstStyle/>
-          <a:p>
-            <a:pPr marL="0" indent="0">
-              <a:buNone/>
-            </a:pPr>
-            <a:r>
-              <a:rPr lang="en-US" sz="1100" i="1" dirty="0">
-                <a:solidFill>
-                  <a:srgbClr val="C0392B"/>
-                </a:solidFill>
-                <a:latin typeface="Calibri" pitchFamily="34" charset="0"/>
-                <a:ea typeface="Calibri" pitchFamily="34" charset="-122"/>
-                <a:cs typeface="Calibri" pitchFamily="34" charset="-120"/>
-              </a:rPr>
-              <a:t>→ Flagged as redundant</a:t>
-            </a:r>
-            <a:endParaRPr lang="en-US" sz="1100" dirty="0"/>
-          </a:p>
-        </p:txBody>
-      </p:sp>
-      <p:sp>
-        <p:nvSpPr>
-          <p:cNvPr id="26" name="TextBox 25">
-            <a:extLst>
-              <a:ext uri="{FF2B5EF4-FFF2-40B4-BE49-F238E27FC236}">
-                <a16:creationId xmlns:a16="http://schemas.microsoft.com/office/drawing/2014/main" id="{EF966B74-3284-4610-8D9F-95ACA56A5E10}"/>
-              </a:ext>
-            </a:extLst>
-          </p:cNvPr>
-          <p:cNvSpPr txBox="1"/>
-          <p:nvPr/>
-        </p:nvSpPr>
-        <p:spPr>
-          <a:xfrm>
-            <a:off x="320040" y="1439342"/>
-            <a:ext cx="4160520" cy="1384995"/>
-          </a:xfrm>
-          <a:prstGeom prst="rect">
-            <a:avLst/>
-          </a:prstGeom>
-          <a:noFill/>
-        </p:spPr>
-        <p:txBody>
-          <a:bodyPr wrap="square">
-            <a:spAutoFit/>
-          </a:bodyPr>
-          <a:lstStyle/>
-          <a:p>
-            <a:r>
-              <a:rPr lang="en-US" sz="1050" dirty="0"/>
-              <a:t>The system uses a multilingual Sentence-Transformer model to compare the meaning of complete sentences, not only individual words.</a:t>
-            </a:r>
-          </a:p>
-          <a:p>
-            <a:r>
-              <a:rPr lang="en-US" sz="1050" dirty="0"/>
-              <a:t>Each sentence is converted into a semantic vector. Then the system calculates cosine similarity between all sentence pairs.</a:t>
-            </a:r>
-          </a:p>
-          <a:p>
-            <a:r>
-              <a:rPr lang="en-US" sz="1050" dirty="0"/>
-              <a:t>If the similarity score is high, the pair is classified as:</a:t>
-            </a:r>
-          </a:p>
-          <a:p>
-            <a:pPr>
-              <a:buFont typeface="Arial" panose="020B0604020202020204" pitchFamily="34" charset="0"/>
-              <a:buChar char="•"/>
-            </a:pPr>
-            <a:r>
-              <a:rPr lang="en-US" sz="1050" b="1" dirty="0"/>
-              <a:t>Duplicate</a:t>
-            </a:r>
-            <a:r>
-              <a:rPr lang="en-US" sz="1050" dirty="0"/>
-              <a:t>: almost identical meaning </a:t>
-            </a:r>
-          </a:p>
-          <a:p>
-            <a:pPr>
-              <a:buFont typeface="Arial" panose="020B0604020202020204" pitchFamily="34" charset="0"/>
-              <a:buChar char="•"/>
-            </a:pPr>
-            <a:r>
-              <a:rPr lang="en-US" sz="1050" b="1" dirty="0"/>
-              <a:t>Manual review</a:t>
-            </a:r>
-            <a:r>
-              <a:rPr lang="en-US" sz="1050" dirty="0"/>
-              <a:t>: user chooses which sentence to keep </a:t>
-            </a:r>
-          </a:p>
-          <a:p>
-            <a:pPr>
-              <a:buFont typeface="Arial" panose="020B0604020202020204" pitchFamily="34" charset="0"/>
-              <a:buChar char="•"/>
-            </a:pPr>
-            <a:r>
-              <a:rPr lang="en-US" sz="1050" b="1" dirty="0"/>
-              <a:t>Merge candidate</a:t>
-            </a:r>
-            <a:r>
-              <a:rPr lang="en-US" sz="1050" dirty="0"/>
-              <a:t>: the system may merge them during rewriting</a:t>
-            </a:r>
-          </a:p>
-        </p:txBody>
-      </p:sp>
-    </p:spTree>
-  </p:cSld>
-  <p:clrMapOvr>
-    <a:masterClrMapping/>
-  </p:clrMapOvr>
-</p:sld>
-</file>
-
-<file path=ppt/slides/slide13.xml><?xml version="1.0" encoding="utf-8"?>
-<p:sld xmlns:a="http://schemas.openxmlformats.org/drawingml/2006/main" xmlns:r="http://schemas.openxmlformats.org/officeDocument/2006/relationships" xmlns:p="http://schemas.openxmlformats.org/presentationml/2006/main">
-  <p:cSld name="Slide 11">
-    <p:bg>
-      <p:bgPr>
-        <a:solidFill>
-          <a:srgbClr val="0D2137"/>
-        </a:solidFill>
-        <a:effectLst/>
-      </p:bgPr>
-    </p:bg>
-    <p:spTree>
-      <p:nvGrpSpPr>
-        <p:cNvPr id="1" name=""/>
-        <p:cNvGrpSpPr/>
-        <p:nvPr/>
-      </p:nvGrpSpPr>
-      <p:grpSpPr>
-        <a:xfrm>
-          <a:off x="0" y="0"/>
-          <a:ext cx="0" cy="0"/>
-          <a:chOff x="0" y="0"/>
-          <a:chExt cx="0" cy="0"/>
-        </a:xfrm>
-      </p:grpSpPr>
-      <p:sp>
-        <p:nvSpPr>
-          <p:cNvPr id="2" name="Text 0"/>
-          <p:cNvSpPr/>
-          <p:nvPr/>
-        </p:nvSpPr>
-        <p:spPr>
-          <a:xfrm>
-            <a:off x="457200" y="182880"/>
-            <a:ext cx="7498080" cy="548640"/>
-          </a:xfrm>
-          <a:prstGeom prst="rect">
-            <a:avLst/>
-          </a:prstGeom>
-          <a:noFill/>
-          <a:ln/>
-        </p:spPr>
-        <p:txBody>
-          <a:bodyPr wrap="square" rtlCol="0" anchor="ctr"/>
-          <a:lstStyle/>
-          <a:p>
-            <a:pPr marL="0" indent="0">
-              <a:buNone/>
-            </a:pPr>
-            <a:r>
-              <a:rPr lang="en-US" sz="2800" b="1" dirty="0">
-                <a:solidFill>
-                  <a:srgbClr val="FFFFFF"/>
-                </a:solidFill>
-                <a:latin typeface="Cambria" pitchFamily="34" charset="0"/>
-                <a:ea typeface="Cambria" pitchFamily="34" charset="-122"/>
-                <a:cs typeface="Cambria" pitchFamily="34" charset="-120"/>
-              </a:rPr>
-              <a:t>Pre-Merging Strategy</a:t>
-            </a:r>
-            <a:endParaRPr lang="en-US" sz="2800" dirty="0"/>
-          </a:p>
-        </p:txBody>
-      </p:sp>
-      <p:sp>
-        <p:nvSpPr>
-          <p:cNvPr id="3" name="Shape 1"/>
-          <p:cNvSpPr/>
-          <p:nvPr/>
-        </p:nvSpPr>
-        <p:spPr>
-          <a:xfrm>
-            <a:off x="7498080" y="182880"/>
-            <a:ext cx="1371600" cy="457200"/>
-          </a:xfrm>
-          <a:prstGeom prst="roundRect">
-            <a:avLst>
-              <a:gd name="adj" fmla="val 12000"/>
-            </a:avLst>
-          </a:prstGeom>
-          <a:solidFill>
-            <a:srgbClr val="C0392B"/>
-          </a:solidFill>
-          <a:ln w="12700">
-            <a:solidFill>
-              <a:srgbClr val="C0392B"/>
-            </a:solidFill>
-            <a:prstDash val="solid"/>
-          </a:ln>
-        </p:spPr>
-      </p:sp>
-      <p:sp>
-        <p:nvSpPr>
-          <p:cNvPr id="5" name="Text 3"/>
-          <p:cNvSpPr/>
-          <p:nvPr/>
-        </p:nvSpPr>
-        <p:spPr>
-          <a:xfrm>
-            <a:off x="457200" y="777240"/>
-            <a:ext cx="8229600" cy="365760"/>
-          </a:xfrm>
-          <a:prstGeom prst="rect">
-            <a:avLst/>
-          </a:prstGeom>
-          <a:noFill/>
-          <a:ln/>
-        </p:spPr>
-        <p:txBody>
-          <a:bodyPr wrap="square" rtlCol="0" anchor="ctr"/>
-          <a:lstStyle/>
-          <a:p>
-            <a:pPr marL="0" indent="0">
-              <a:buNone/>
-            </a:pPr>
-            <a:r>
-              <a:rPr lang="en-US" sz="1300" i="1" dirty="0">
-                <a:solidFill>
-                  <a:srgbClr val="94A3B8"/>
-                </a:solidFill>
-                <a:latin typeface="Calibri" pitchFamily="34" charset="0"/>
-                <a:ea typeface="Calibri" pitchFamily="34" charset="-122"/>
-                <a:cs typeface="Calibri" pitchFamily="34" charset="-120"/>
-              </a:rPr>
-              <a:t>Why is this needed?  If we directly pass both sentences to the AI, information may be lost.</a:t>
-            </a:r>
-            <a:endParaRPr lang="en-US" sz="1300" dirty="0"/>
-          </a:p>
-        </p:txBody>
-      </p:sp>
-      <p:sp>
-        <p:nvSpPr>
-          <p:cNvPr id="6" name="Shape 4"/>
-          <p:cNvSpPr/>
-          <p:nvPr/>
-        </p:nvSpPr>
-        <p:spPr>
-          <a:xfrm>
-            <a:off x="3200400" y="1234440"/>
-            <a:ext cx="3200400" cy="502920"/>
-          </a:xfrm>
-          <a:prstGeom prst="roundRect">
-            <a:avLst>
-              <a:gd name="adj" fmla="val 14545"/>
-            </a:avLst>
-          </a:prstGeom>
-          <a:solidFill>
-            <a:srgbClr val="1E3A5F"/>
-          </a:solidFill>
-          <a:ln w="12700">
-            <a:solidFill>
-              <a:srgbClr val="02C39A"/>
-            </a:solidFill>
-            <a:prstDash val="solid"/>
-          </a:ln>
-        </p:spPr>
-      </p:sp>
-      <p:sp>
-        <p:nvSpPr>
-          <p:cNvPr id="7" name="Text 5"/>
-          <p:cNvSpPr/>
-          <p:nvPr/>
-        </p:nvSpPr>
-        <p:spPr>
-          <a:xfrm>
-            <a:off x="3200400" y="1234440"/>
-            <a:ext cx="3200400" cy="502920"/>
-          </a:xfrm>
-          <a:prstGeom prst="rect">
-            <a:avLst/>
-          </a:prstGeom>
-          <a:noFill/>
-          <a:ln/>
-        </p:spPr>
-        <p:txBody>
-          <a:bodyPr wrap="square" rtlCol="0" anchor="ctr"/>
-          <a:lstStyle/>
-          <a:p>
-            <a:pPr marL="0" indent="0" algn="ctr">
-              <a:buNone/>
-            </a:pPr>
-            <a:r>
-              <a:rPr lang="en-US" sz="1400" b="1" dirty="0">
-                <a:solidFill>
-                  <a:srgbClr val="02C39A"/>
-                </a:solidFill>
-                <a:latin typeface="Calibri" pitchFamily="34" charset="0"/>
-                <a:ea typeface="Calibri" pitchFamily="34" charset="-122"/>
-                <a:cs typeface="Calibri" pitchFamily="34" charset="-120"/>
-              </a:rPr>
-              <a:t>Sentence Pair</a:t>
-            </a:r>
-            <a:endParaRPr lang="en-US" sz="1400" dirty="0"/>
-          </a:p>
-        </p:txBody>
-      </p:sp>
-      <p:sp>
-        <p:nvSpPr>
-          <p:cNvPr id="8" name="Text 6"/>
-          <p:cNvSpPr/>
-          <p:nvPr/>
-        </p:nvSpPr>
-        <p:spPr>
-          <a:xfrm>
-            <a:off x="3200400" y="1737360"/>
-            <a:ext cx="3200400" cy="320040"/>
-          </a:xfrm>
-          <a:prstGeom prst="rect">
-            <a:avLst/>
-          </a:prstGeom>
-          <a:noFill/>
-          <a:ln/>
-        </p:spPr>
-        <p:txBody>
-          <a:bodyPr wrap="square" rtlCol="0" anchor="ctr"/>
-          <a:lstStyle/>
-          <a:p>
-            <a:pPr marL="0" indent="0" algn="ctr">
-              <a:buNone/>
-            </a:pPr>
-            <a:r>
-              <a:rPr lang="en-US" sz="1600" dirty="0">
-                <a:solidFill>
-                  <a:srgbClr val="94A3B8"/>
-                </a:solidFill>
-              </a:rPr>
-              <a:t>↓</a:t>
-            </a:r>
-            <a:endParaRPr lang="en-US" sz="1600" dirty="0"/>
-          </a:p>
-        </p:txBody>
-      </p:sp>
-      <p:sp>
-        <p:nvSpPr>
-          <p:cNvPr id="9" name="Shape 7"/>
-          <p:cNvSpPr/>
-          <p:nvPr/>
-        </p:nvSpPr>
-        <p:spPr>
-          <a:xfrm>
-            <a:off x="3200400" y="2057400"/>
-            <a:ext cx="3200400" cy="502920"/>
-          </a:xfrm>
-          <a:prstGeom prst="roundRect">
-            <a:avLst>
-              <a:gd name="adj" fmla="val 14545"/>
-            </a:avLst>
-          </a:prstGeom>
-          <a:solidFill>
-            <a:srgbClr val="1E3A5F"/>
-          </a:solidFill>
-          <a:ln w="12700">
-            <a:solidFill>
-              <a:srgbClr val="028090"/>
-            </a:solidFill>
-            <a:prstDash val="solid"/>
-          </a:ln>
-        </p:spPr>
-      </p:sp>
-      <p:sp>
-        <p:nvSpPr>
-          <p:cNvPr id="10" name="Text 8"/>
-          <p:cNvSpPr/>
-          <p:nvPr/>
-        </p:nvSpPr>
-        <p:spPr>
-          <a:xfrm>
-            <a:off x="3200400" y="2057400"/>
-            <a:ext cx="3200400" cy="502920"/>
-          </a:xfrm>
-          <a:prstGeom prst="rect">
-            <a:avLst/>
-          </a:prstGeom>
-          <a:noFill/>
-          <a:ln/>
-        </p:spPr>
-        <p:txBody>
-          <a:bodyPr wrap="square" rtlCol="0" anchor="ctr"/>
-          <a:lstStyle/>
-          <a:p>
-            <a:pPr marL="0" indent="0" algn="ctr">
-              <a:buNone/>
-            </a:pPr>
-            <a:r>
-              <a:rPr lang="en-US" sz="1300" b="1" dirty="0">
-                <a:solidFill>
-                  <a:srgbClr val="FFFFFF"/>
-                </a:solidFill>
-                <a:latin typeface="Calibri" pitchFamily="34" charset="0"/>
-                <a:ea typeface="Calibri" pitchFamily="34" charset="-122"/>
-                <a:cs typeface="Calibri" pitchFamily="34" charset="-120"/>
-              </a:rPr>
-              <a:t>Similarity Score (</a:t>
-            </a:r>
-            <a:r>
-              <a:rPr lang="tr-TR" sz="1300" b="1" dirty="0">
-                <a:solidFill>
-                  <a:srgbClr val="FFFFFF"/>
-                </a:solidFill>
-                <a:latin typeface="Calibri" pitchFamily="34" charset="0"/>
-                <a:ea typeface="Calibri" pitchFamily="34" charset="-122"/>
-                <a:cs typeface="Calibri" pitchFamily="34" charset="-120"/>
-              </a:rPr>
-              <a:t>Sentence -Tranformers</a:t>
-            </a:r>
-            <a:r>
-              <a:rPr lang="en-US" sz="1300" b="1" dirty="0">
-                <a:solidFill>
-                  <a:srgbClr val="FFFFFF"/>
-                </a:solidFill>
-                <a:latin typeface="Calibri" pitchFamily="34" charset="0"/>
-                <a:ea typeface="Calibri" pitchFamily="34" charset="-122"/>
-                <a:cs typeface="Calibri" pitchFamily="34" charset="-120"/>
-              </a:rPr>
-              <a:t>)</a:t>
-            </a:r>
-            <a:endParaRPr lang="en-US" sz="1300" dirty="0"/>
-          </a:p>
-        </p:txBody>
-      </p:sp>
-      <p:sp>
-        <p:nvSpPr>
-          <p:cNvPr id="11" name="Text 9"/>
-          <p:cNvSpPr/>
-          <p:nvPr/>
-        </p:nvSpPr>
-        <p:spPr>
-          <a:xfrm>
-            <a:off x="3200400" y="2560320"/>
-            <a:ext cx="3200400" cy="320040"/>
-          </a:xfrm>
-          <a:prstGeom prst="rect">
-            <a:avLst/>
-          </a:prstGeom>
-          <a:noFill/>
-          <a:ln/>
-        </p:spPr>
-        <p:txBody>
-          <a:bodyPr wrap="square" rtlCol="0" anchor="ctr"/>
-          <a:lstStyle/>
-          <a:p>
-            <a:pPr marL="0" indent="0" algn="ctr">
-              <a:buNone/>
-            </a:pPr>
-            <a:r>
-              <a:rPr lang="en-US" sz="1600" dirty="0">
-                <a:solidFill>
-                  <a:srgbClr val="94A3B8"/>
-                </a:solidFill>
-              </a:rPr>
-              <a:t>↓</a:t>
-            </a:r>
-            <a:endParaRPr lang="en-US" sz="1600" dirty="0"/>
-          </a:p>
-        </p:txBody>
-      </p:sp>
-      <p:sp>
-        <p:nvSpPr>
-          <p:cNvPr id="12" name="Shape 10"/>
-          <p:cNvSpPr/>
-          <p:nvPr/>
-        </p:nvSpPr>
-        <p:spPr>
-          <a:xfrm>
-            <a:off x="182880" y="2880360"/>
-            <a:ext cx="2926080" cy="685800"/>
-          </a:xfrm>
-          <a:prstGeom prst="roundRect">
-            <a:avLst>
-              <a:gd name="adj" fmla="val 10667"/>
-            </a:avLst>
-          </a:prstGeom>
-          <a:solidFill>
-            <a:srgbClr val="C0392B"/>
-          </a:solidFill>
-          <a:ln w="12700">
-            <a:solidFill>
-              <a:srgbClr val="C0392B"/>
-            </a:solidFill>
-            <a:prstDash val="solid"/>
-          </a:ln>
-          <a:effectLst>
-            <a:outerShdw blurRad="101600" dist="38100" dir="2700000" algn="bl" rotWithShape="0">
-              <a:srgbClr val="000000">
-                <a:alpha val="12000"/>
-              </a:srgbClr>
-            </a:outerShdw>
-          </a:effectLst>
-        </p:spPr>
-      </p:sp>
-      <p:sp>
-        <p:nvSpPr>
-          <p:cNvPr id="13" name="Text 11"/>
-          <p:cNvSpPr/>
-          <p:nvPr/>
-        </p:nvSpPr>
-        <p:spPr>
-          <a:xfrm>
-            <a:off x="182880" y="2880360"/>
-            <a:ext cx="2926080" cy="685800"/>
-          </a:xfrm>
-          <a:prstGeom prst="rect">
-            <a:avLst/>
-          </a:prstGeom>
-          <a:noFill/>
-          <a:ln/>
-        </p:spPr>
-        <p:txBody>
-          <a:bodyPr wrap="square" rtlCol="0" anchor="ctr"/>
-          <a:lstStyle/>
-          <a:p>
-            <a:pPr marL="0" indent="0" algn="ctr">
-              <a:buNone/>
-            </a:pPr>
-            <a:r>
-              <a:rPr lang="en-US" sz="1100" b="1" dirty="0">
-                <a:solidFill>
-                  <a:srgbClr val="FFFFFF"/>
-                </a:solidFill>
-                <a:latin typeface="Calibri" pitchFamily="34" charset="0"/>
-                <a:ea typeface="Calibri" pitchFamily="34" charset="-122"/>
-                <a:cs typeface="Calibri" pitchFamily="34" charset="-120"/>
-              </a:rPr>
-              <a:t>Score &gt; Delete</a:t>
-            </a:r>
-            <a:endParaRPr lang="en-US" sz="1100" dirty="0"/>
-          </a:p>
-          <a:p>
-            <a:pPr marL="0" indent="0" algn="ctr">
-              <a:buNone/>
-            </a:pPr>
-            <a:r>
-              <a:rPr lang="en-US" sz="1100" b="1" dirty="0">
-                <a:solidFill>
-                  <a:srgbClr val="FFFFFF"/>
-                </a:solidFill>
-                <a:latin typeface="Calibri" pitchFamily="34" charset="0"/>
-                <a:ea typeface="Calibri" pitchFamily="34" charset="-122"/>
-                <a:cs typeface="Calibri" pitchFamily="34" charset="-120"/>
-              </a:rPr>
-              <a:t>Threshold</a:t>
-            </a:r>
-            <a:endParaRPr lang="en-US" sz="1100" dirty="0"/>
-          </a:p>
-        </p:txBody>
-      </p:sp>
-      <p:sp>
-        <p:nvSpPr>
-          <p:cNvPr id="14" name="Text 12"/>
-          <p:cNvSpPr/>
-          <p:nvPr/>
-        </p:nvSpPr>
-        <p:spPr>
-          <a:xfrm>
-            <a:off x="182880" y="3566160"/>
-            <a:ext cx="2926080" cy="320040"/>
-          </a:xfrm>
-          <a:prstGeom prst="rect">
-            <a:avLst/>
-          </a:prstGeom>
-          <a:noFill/>
-          <a:ln/>
-        </p:spPr>
-        <p:txBody>
-          <a:bodyPr wrap="square" rtlCol="0" anchor="ctr"/>
-          <a:lstStyle/>
-          <a:p>
-            <a:pPr marL="0" indent="0" algn="ctr">
-              <a:buNone/>
-            </a:pPr>
-            <a:r>
-              <a:rPr lang="en-US" sz="1400" dirty="0">
-                <a:solidFill>
-                  <a:srgbClr val="94A3B8"/>
-                </a:solidFill>
-              </a:rPr>
-              <a:t>↓</a:t>
-            </a:r>
-            <a:endParaRPr lang="en-US" sz="1400" dirty="0"/>
-          </a:p>
-        </p:txBody>
-      </p:sp>
-      <p:sp>
-        <p:nvSpPr>
-          <p:cNvPr id="15" name="Shape 13"/>
-          <p:cNvSpPr/>
-          <p:nvPr/>
-        </p:nvSpPr>
-        <p:spPr>
-          <a:xfrm>
-            <a:off x="182880" y="3886200"/>
-            <a:ext cx="2926080" cy="594360"/>
-          </a:xfrm>
-          <a:prstGeom prst="roundRect">
-            <a:avLst>
-              <a:gd name="adj" fmla="val 12308"/>
-            </a:avLst>
-          </a:prstGeom>
-          <a:solidFill>
-            <a:srgbClr val="7F1D1D"/>
-          </a:solidFill>
-          <a:ln w="12700">
-            <a:solidFill>
-              <a:srgbClr val="C0392B"/>
-            </a:solidFill>
-            <a:prstDash val="solid"/>
-          </a:ln>
-        </p:spPr>
-        <p:txBody>
-          <a:bodyPr/>
-          <a:lstStyle/>
-          <a:p>
-            <a:endParaRPr lang="en-US" dirty="0"/>
-          </a:p>
-        </p:txBody>
-      </p:sp>
-      <p:sp>
-        <p:nvSpPr>
-          <p:cNvPr id="16" name="Text 14"/>
-          <p:cNvSpPr/>
-          <p:nvPr/>
-        </p:nvSpPr>
-        <p:spPr>
-          <a:xfrm>
-            <a:off x="182880" y="3886200"/>
-            <a:ext cx="2926080" cy="594360"/>
-          </a:xfrm>
-          <a:prstGeom prst="rect">
-            <a:avLst/>
-          </a:prstGeom>
-          <a:noFill/>
-          <a:ln/>
-        </p:spPr>
-        <p:txBody>
-          <a:bodyPr wrap="square" rtlCol="0" anchor="ctr"/>
-          <a:lstStyle/>
-          <a:p>
-            <a:pPr marL="0" indent="0" algn="ctr">
-              <a:buNone/>
-            </a:pPr>
-            <a:r>
-              <a:rPr lang="tr-TR" sz="1200" b="1" dirty="0">
-                <a:solidFill>
-                  <a:srgbClr val="02C39A"/>
-                </a:solidFill>
-                <a:latin typeface="Calibri" pitchFamily="34" charset="0"/>
-                <a:ea typeface="Calibri" pitchFamily="34" charset="-122"/>
-                <a:cs typeface="Calibri" pitchFamily="34" charset="-120"/>
-              </a:rPr>
-              <a:t>Let User choose what to keep</a:t>
-            </a:r>
-            <a:endParaRPr lang="en-US" sz="1200" dirty="0"/>
-          </a:p>
-        </p:txBody>
-      </p:sp>
-      <p:sp>
-        <p:nvSpPr>
-          <p:cNvPr id="17" name="Shape 15"/>
-          <p:cNvSpPr/>
-          <p:nvPr/>
-        </p:nvSpPr>
-        <p:spPr>
-          <a:xfrm>
-            <a:off x="3017520" y="2880360"/>
-            <a:ext cx="2926080" cy="685800"/>
-          </a:xfrm>
-          <a:prstGeom prst="roundRect">
-            <a:avLst>
-              <a:gd name="adj" fmla="val 10667"/>
-            </a:avLst>
-          </a:prstGeom>
-          <a:solidFill>
-            <a:srgbClr val="92400E"/>
-          </a:solidFill>
-          <a:ln w="12700">
-            <a:solidFill>
-              <a:srgbClr val="92400E"/>
-            </a:solidFill>
-            <a:prstDash val="solid"/>
-          </a:ln>
-          <a:effectLst>
-            <a:outerShdw blurRad="101600" dist="38100" dir="2700000" algn="bl" rotWithShape="0">
-              <a:srgbClr val="000000">
-                <a:alpha val="12000"/>
-              </a:srgbClr>
-            </a:outerShdw>
-          </a:effectLst>
-        </p:spPr>
-      </p:sp>
-      <p:sp>
-        <p:nvSpPr>
-          <p:cNvPr id="18" name="Text 16"/>
-          <p:cNvSpPr/>
-          <p:nvPr/>
-        </p:nvSpPr>
-        <p:spPr>
-          <a:xfrm>
-            <a:off x="3017520" y="2880360"/>
-            <a:ext cx="2926080" cy="685800"/>
-          </a:xfrm>
-          <a:prstGeom prst="rect">
-            <a:avLst/>
-          </a:prstGeom>
-          <a:noFill/>
-          <a:ln/>
-        </p:spPr>
-        <p:txBody>
-          <a:bodyPr wrap="square" rtlCol="0" anchor="ctr"/>
-          <a:lstStyle/>
-          <a:p>
-            <a:pPr marL="0" indent="0" algn="ctr">
-              <a:buNone/>
-            </a:pPr>
-            <a:r>
-              <a:rPr lang="en-US" sz="1100" b="1" dirty="0">
-                <a:solidFill>
-                  <a:srgbClr val="FFFFFF"/>
-                </a:solidFill>
-                <a:latin typeface="Calibri" pitchFamily="34" charset="0"/>
-                <a:ea typeface="Calibri" pitchFamily="34" charset="-122"/>
-                <a:cs typeface="Calibri" pitchFamily="34" charset="-120"/>
-              </a:rPr>
-              <a:t>Merge &lt; Score &lt;</a:t>
-            </a:r>
-            <a:endParaRPr lang="en-US" sz="1100" dirty="0"/>
-          </a:p>
-          <a:p>
-            <a:pPr marL="0" indent="0" algn="ctr">
-              <a:buNone/>
-            </a:pPr>
-            <a:r>
-              <a:rPr lang="en-US" sz="1100" b="1" dirty="0">
-                <a:solidFill>
-                  <a:srgbClr val="FFFFFF"/>
-                </a:solidFill>
-                <a:latin typeface="Calibri" pitchFamily="34" charset="0"/>
-                <a:ea typeface="Calibri" pitchFamily="34" charset="-122"/>
-                <a:cs typeface="Calibri" pitchFamily="34" charset="-120"/>
-              </a:rPr>
-              <a:t>Delete Threshold</a:t>
-            </a:r>
-            <a:endParaRPr lang="en-US" sz="1100" dirty="0"/>
-          </a:p>
-        </p:txBody>
-      </p:sp>
-      <p:sp>
-        <p:nvSpPr>
-          <p:cNvPr id="19" name="Text 17"/>
-          <p:cNvSpPr/>
-          <p:nvPr/>
-        </p:nvSpPr>
-        <p:spPr>
-          <a:xfrm>
-            <a:off x="3017520" y="3566160"/>
-            <a:ext cx="2926080" cy="320040"/>
-          </a:xfrm>
-          <a:prstGeom prst="rect">
-            <a:avLst/>
-          </a:prstGeom>
-          <a:noFill/>
-          <a:ln/>
-        </p:spPr>
-        <p:txBody>
-          <a:bodyPr wrap="square" rtlCol="0" anchor="ctr"/>
-          <a:lstStyle/>
-          <a:p>
-            <a:pPr marL="0" indent="0" algn="ctr">
-              <a:buNone/>
-            </a:pPr>
-            <a:r>
-              <a:rPr lang="en-US" sz="1400" dirty="0">
-                <a:solidFill>
-                  <a:srgbClr val="94A3B8"/>
-                </a:solidFill>
-              </a:rPr>
-              <a:t>↓</a:t>
-            </a:r>
-            <a:endParaRPr lang="en-US" sz="1400" dirty="0"/>
-          </a:p>
-        </p:txBody>
-      </p:sp>
-      <p:sp>
-        <p:nvSpPr>
-          <p:cNvPr id="20" name="Shape 18"/>
-          <p:cNvSpPr/>
-          <p:nvPr/>
-        </p:nvSpPr>
-        <p:spPr>
-          <a:xfrm>
-            <a:off x="3017520" y="3886200"/>
-            <a:ext cx="2926080" cy="594360"/>
-          </a:xfrm>
-          <a:prstGeom prst="roundRect">
-            <a:avLst>
-              <a:gd name="adj" fmla="val 12308"/>
-            </a:avLst>
-          </a:prstGeom>
-          <a:solidFill>
-            <a:srgbClr val="451A03"/>
-          </a:solidFill>
-          <a:ln w="12700">
-            <a:solidFill>
-              <a:srgbClr val="92400E"/>
-            </a:solidFill>
-            <a:prstDash val="solid"/>
-          </a:ln>
-        </p:spPr>
-      </p:sp>
-      <p:sp>
-        <p:nvSpPr>
-          <p:cNvPr id="21" name="Text 19"/>
-          <p:cNvSpPr/>
-          <p:nvPr/>
-        </p:nvSpPr>
-        <p:spPr>
-          <a:xfrm>
-            <a:off x="3017520" y="3886200"/>
-            <a:ext cx="2926080" cy="594360"/>
-          </a:xfrm>
-          <a:prstGeom prst="rect">
-            <a:avLst/>
-          </a:prstGeom>
-          <a:noFill/>
-          <a:ln/>
-        </p:spPr>
-        <p:txBody>
-          <a:bodyPr wrap="square" rtlCol="0" anchor="ctr"/>
-          <a:lstStyle/>
-          <a:p>
-            <a:pPr marL="0" indent="0" algn="ctr">
-              <a:buNone/>
-            </a:pPr>
-            <a:r>
-              <a:rPr lang="en-US" sz="1200" b="1" dirty="0">
-                <a:solidFill>
-                  <a:srgbClr val="02C39A"/>
-                </a:solidFill>
-                <a:latin typeface="Calibri" pitchFamily="34" charset="0"/>
-                <a:ea typeface="Calibri" pitchFamily="34" charset="-122"/>
-                <a:cs typeface="Calibri" pitchFamily="34" charset="-120"/>
-              </a:rPr>
-              <a:t>Send as Merge</a:t>
-            </a:r>
-            <a:endParaRPr lang="en-US" sz="1200" dirty="0"/>
-          </a:p>
-          <a:p>
-            <a:pPr marL="0" indent="0" algn="ctr">
-              <a:buNone/>
-            </a:pPr>
-            <a:r>
-              <a:rPr lang="en-US" sz="1200" b="1" dirty="0">
-                <a:solidFill>
-                  <a:srgbClr val="02C39A"/>
-                </a:solidFill>
-                <a:latin typeface="Calibri" pitchFamily="34" charset="0"/>
-                <a:ea typeface="Calibri" pitchFamily="34" charset="-122"/>
-                <a:cs typeface="Calibri" pitchFamily="34" charset="-120"/>
-              </a:rPr>
-              <a:t>Candidate</a:t>
-            </a:r>
-            <a:endParaRPr lang="en-US" sz="1200" dirty="0"/>
-          </a:p>
-        </p:txBody>
-      </p:sp>
-      <p:sp>
-        <p:nvSpPr>
-          <p:cNvPr id="22" name="Shape 20"/>
-          <p:cNvSpPr/>
-          <p:nvPr/>
-        </p:nvSpPr>
-        <p:spPr>
-          <a:xfrm>
-            <a:off x="5852160" y="2880360"/>
-            <a:ext cx="2926080" cy="685800"/>
-          </a:xfrm>
-          <a:prstGeom prst="roundRect">
-            <a:avLst>
-              <a:gd name="adj" fmla="val 10667"/>
-            </a:avLst>
-          </a:prstGeom>
-          <a:solidFill>
-            <a:srgbClr val="166534"/>
-          </a:solidFill>
-          <a:ln w="12700">
-            <a:solidFill>
-              <a:srgbClr val="166534"/>
-            </a:solidFill>
-            <a:prstDash val="solid"/>
-          </a:ln>
-          <a:effectLst>
-            <a:outerShdw blurRad="101600" dist="38100" dir="2700000" algn="bl" rotWithShape="0">
-              <a:srgbClr val="000000">
-                <a:alpha val="12000"/>
-              </a:srgbClr>
-            </a:outerShdw>
-          </a:effectLst>
-        </p:spPr>
-      </p:sp>
-      <p:sp>
-        <p:nvSpPr>
-          <p:cNvPr id="23" name="Text 21"/>
-          <p:cNvSpPr/>
-          <p:nvPr/>
-        </p:nvSpPr>
-        <p:spPr>
-          <a:xfrm>
-            <a:off x="5852160" y="2880360"/>
-            <a:ext cx="2926080" cy="685800"/>
-          </a:xfrm>
-          <a:prstGeom prst="rect">
-            <a:avLst/>
-          </a:prstGeom>
-          <a:noFill/>
-          <a:ln/>
-        </p:spPr>
-        <p:txBody>
-          <a:bodyPr wrap="square" rtlCol="0" anchor="ctr"/>
-          <a:lstStyle/>
-          <a:p>
-            <a:pPr marL="0" indent="0" algn="ctr">
-              <a:buNone/>
-            </a:pPr>
-            <a:r>
-              <a:rPr lang="en-US" sz="1100" b="1" dirty="0">
-                <a:solidFill>
-                  <a:srgbClr val="FFFFFF"/>
-                </a:solidFill>
-                <a:latin typeface="Calibri" pitchFamily="34" charset="0"/>
-                <a:ea typeface="Calibri" pitchFamily="34" charset="-122"/>
-                <a:cs typeface="Calibri" pitchFamily="34" charset="-120"/>
-              </a:rPr>
-              <a:t>Score &lt; Merge</a:t>
-            </a:r>
-            <a:endParaRPr lang="en-US" sz="1100" dirty="0"/>
-          </a:p>
-          <a:p>
-            <a:pPr marL="0" indent="0" algn="ctr">
-              <a:buNone/>
-            </a:pPr>
-            <a:r>
-              <a:rPr lang="en-US" sz="1100" b="1" dirty="0">
-                <a:solidFill>
-                  <a:srgbClr val="FFFFFF"/>
-                </a:solidFill>
-                <a:latin typeface="Calibri" pitchFamily="34" charset="0"/>
-                <a:ea typeface="Calibri" pitchFamily="34" charset="-122"/>
-                <a:cs typeface="Calibri" pitchFamily="34" charset="-120"/>
-              </a:rPr>
-              <a:t>Threshold</a:t>
-            </a:r>
-            <a:endParaRPr lang="en-US" sz="1100" dirty="0"/>
-          </a:p>
-        </p:txBody>
-      </p:sp>
-      <p:sp>
-        <p:nvSpPr>
-          <p:cNvPr id="24" name="Text 22"/>
-          <p:cNvSpPr/>
-          <p:nvPr/>
-        </p:nvSpPr>
-        <p:spPr>
-          <a:xfrm>
-            <a:off x="5852160" y="3566160"/>
-            <a:ext cx="2926080" cy="320040"/>
-          </a:xfrm>
-          <a:prstGeom prst="rect">
-            <a:avLst/>
-          </a:prstGeom>
-          <a:noFill/>
-          <a:ln/>
-        </p:spPr>
-        <p:txBody>
-          <a:bodyPr wrap="square" rtlCol="0" anchor="ctr"/>
-          <a:lstStyle/>
-          <a:p>
-            <a:pPr marL="0" indent="0" algn="ctr">
-              <a:buNone/>
-            </a:pPr>
-            <a:r>
-              <a:rPr lang="en-US" sz="1400" dirty="0">
-                <a:solidFill>
-                  <a:srgbClr val="94A3B8"/>
-                </a:solidFill>
-              </a:rPr>
-              <a:t>↓</a:t>
-            </a:r>
-            <a:endParaRPr lang="en-US" sz="1400" dirty="0"/>
-          </a:p>
-        </p:txBody>
-      </p:sp>
-      <p:sp>
-        <p:nvSpPr>
-          <p:cNvPr id="25" name="Shape 23"/>
-          <p:cNvSpPr/>
-          <p:nvPr/>
-        </p:nvSpPr>
-        <p:spPr>
-          <a:xfrm>
-            <a:off x="5852160" y="3886200"/>
-            <a:ext cx="2926080" cy="594360"/>
-          </a:xfrm>
-          <a:prstGeom prst="roundRect">
-            <a:avLst>
-              <a:gd name="adj" fmla="val 12308"/>
-            </a:avLst>
-          </a:prstGeom>
-          <a:solidFill>
-            <a:srgbClr val="052E16"/>
-          </a:solidFill>
-          <a:ln w="12700">
-            <a:solidFill>
-              <a:srgbClr val="166534"/>
-            </a:solidFill>
-            <a:prstDash val="solid"/>
-          </a:ln>
-        </p:spPr>
-      </p:sp>
-      <p:sp>
-        <p:nvSpPr>
-          <p:cNvPr id="26" name="Text 24"/>
-          <p:cNvSpPr/>
-          <p:nvPr/>
-        </p:nvSpPr>
-        <p:spPr>
-          <a:xfrm>
-            <a:off x="5852160" y="3886200"/>
-            <a:ext cx="2926080" cy="594360"/>
-          </a:xfrm>
-          <a:prstGeom prst="rect">
-            <a:avLst/>
-          </a:prstGeom>
-          <a:noFill/>
-          <a:ln/>
-        </p:spPr>
-        <p:txBody>
-          <a:bodyPr wrap="square" rtlCol="0" anchor="ctr"/>
-          <a:lstStyle/>
-          <a:p>
-            <a:pPr marL="0" indent="0" algn="ctr">
-              <a:buNone/>
-            </a:pPr>
-            <a:r>
-              <a:rPr lang="en-US" sz="1200" b="1" dirty="0">
-                <a:solidFill>
-                  <a:srgbClr val="02C39A"/>
-                </a:solidFill>
-                <a:latin typeface="Calibri" pitchFamily="34" charset="0"/>
-                <a:ea typeface="Calibri" pitchFamily="34" charset="-122"/>
-                <a:cs typeface="Calibri" pitchFamily="34" charset="-120"/>
-              </a:rPr>
-              <a:t>Keep Unchanged</a:t>
-            </a:r>
-            <a:endParaRPr lang="en-US" sz="1200" dirty="0"/>
-          </a:p>
-        </p:txBody>
-      </p:sp>
-    </p:spTree>
   </p:cSld>
   <p:clrMapOvr>
     <a:masterClrMapping/>
@@ -4876,7 +4870,18 @@
                 <a:ea typeface="Calibri" pitchFamily="34" charset="-122"/>
                 <a:cs typeface="Calibri" pitchFamily="34" charset="-120"/>
               </a:rPr>
-              <a:t>1.  Collect analysis results</a:t>
+              <a:t>1.  </a:t>
+            </a:r>
+            <a:r>
+              <a:rPr lang="tr-TR" sz="1200" dirty="0">
+                <a:solidFill>
+                  <a:srgbClr val="9A3412"/>
+                </a:solidFill>
+                <a:latin typeface="Calibri" pitchFamily="34" charset="0"/>
+                <a:ea typeface="Calibri" pitchFamily="34" charset="-122"/>
+                <a:cs typeface="Calibri" pitchFamily="34" charset="-120"/>
+              </a:rPr>
+              <a:t>Get text </a:t>
             </a:r>
             <a:endParaRPr lang="en-US" sz="1200" dirty="0"/>
           </a:p>
@@ -9417,10 +9422,10 @@
       </p:sp>
       <p:pic>
         <p:nvPicPr>
-          <p:cNvPr id="33" name="Picture 32">
+          <p:cNvPr id="5" name="Picture 4">
             <a:extLst>
               <a:ext uri="{FF2B5EF4-FFF2-40B4-BE49-F238E27FC236}">
-                <a16:creationId xmlns:a16="http://schemas.microsoft.com/office/drawing/2014/main" id="{EEC6DEA4-DF8B-4ED7-9056-6774FFC7DADD}"/>
+                <a16:creationId xmlns:a16="http://schemas.microsoft.com/office/drawing/2014/main" id="{4D2B5E3B-3ACD-4D5E-880B-9CBB53010FEF}"/>
               </a:ext>
             </a:extLst>
           </p:cNvPr>
@@ -9437,8 +9442,8 @@
         </p:blipFill>
         <p:spPr>
           <a:xfrm>
-            <a:off x="409242" y="1710497"/>
-            <a:ext cx="8130486" cy="2351389"/>
+            <a:off x="2262923" y="963113"/>
+            <a:ext cx="4304132" cy="3924356"/>
           </a:xfrm>
           <a:prstGeom prst="rect">
             <a:avLst/>
@@ -9544,10 +9549,10 @@
       </p:sp>
       <p:pic>
         <p:nvPicPr>
-          <p:cNvPr id="28" name="Picture 27">
+          <p:cNvPr id="5" name="Picture 4">
             <a:extLst>
               <a:ext uri="{FF2B5EF4-FFF2-40B4-BE49-F238E27FC236}">
-                <a16:creationId xmlns:a16="http://schemas.microsoft.com/office/drawing/2014/main" id="{B507A0C9-09A9-4246-A54B-967FEB92DD0D}"/>
+                <a16:creationId xmlns:a16="http://schemas.microsoft.com/office/drawing/2014/main" id="{6D7D7BF8-88FB-425B-9B21-E81CB89BE187}"/>
               </a:ext>
             </a:extLst>
           </p:cNvPr>
@@ -9564,8 +9569,8 @@
         </p:blipFill>
         <p:spPr>
           <a:xfrm>
-            <a:off x="457200" y="984738"/>
-            <a:ext cx="1682394" cy="3973324"/>
+            <a:off x="2763861" y="945291"/>
+            <a:ext cx="3208514" cy="4198209"/>
           </a:xfrm>
           <a:prstGeom prst="rect">
             <a:avLst/>
@@ -9721,7 +9726,7 @@
               <a:buNone/>
             </a:pPr>
             <a:r>
-              <a:rPr lang="en-US" sz="1400" b="1" dirty="0">
+              <a:rPr lang="en-US" sz="1400" b="1" dirty="0" err="1">
                 <a:solidFill>
                   <a:srgbClr val="02C39A"/>
                 </a:solidFill>
@@ -9730,6 +9735,17 @@
                 <a:cs typeface="Calibri" pitchFamily="34" charset="-120"/>
               </a:rPr>
               <a:t>LanguageTool</a:t>
+            </a:r>
+            <a:r>
+              <a:rPr lang="tr-TR" sz="1400" b="1" dirty="0">
+                <a:solidFill>
+                  <a:srgbClr val="02C39A"/>
+                </a:solidFill>
+                <a:latin typeface="Calibri" pitchFamily="34" charset="0"/>
+                <a:ea typeface="Calibri" pitchFamily="34" charset="-122"/>
+                <a:cs typeface="Calibri" pitchFamily="34" charset="-120"/>
+              </a:rPr>
+              <a:t>,spyCy</a:t>
             </a:r>
             <a:endParaRPr lang="en-US" sz="1400" dirty="0"/>
           </a:p>
@@ -10302,10 +10318,10 @@
       </p:sp>
       <p:pic>
         <p:nvPicPr>
-          <p:cNvPr id="25" name="Picture 24">
+          <p:cNvPr id="5" name="Picture 4">
             <a:extLst>
               <a:ext uri="{FF2B5EF4-FFF2-40B4-BE49-F238E27FC236}">
-                <a16:creationId xmlns:a16="http://schemas.microsoft.com/office/drawing/2014/main" id="{F48DD357-FC57-412D-9B47-8A5FB52EC760}"/>
+                <a16:creationId xmlns:a16="http://schemas.microsoft.com/office/drawing/2014/main" id="{CFF103AD-8CC0-4D4B-BE9B-39B9B9B1C2EA}"/>
               </a:ext>
             </a:extLst>
           </p:cNvPr>
@@ -10322,8 +10338,8 @@
         </p:blipFill>
         <p:spPr>
           <a:xfrm>
-            <a:off x="665018" y="1528732"/>
-            <a:ext cx="8229600" cy="2086035"/>
+            <a:off x="457200" y="1604122"/>
+            <a:ext cx="8459799" cy="2165236"/>
           </a:xfrm>
           <a:prstGeom prst="rect">
             <a:avLst/>

</xml_diff>